<commit_message>
Session 1 v4: rebuild 45-min exercise (5 phases) with a dedicated Hebrew-vs-English experiment; 27 slides, notes updated
</commit_message>
<xml_diff>
--- a/sessions/session-01-intro-vibe-coding.pptx
+++ b/sessions/session-01-intro-vibe-coding.pptx
@@ -31,9 +31,10 @@
     <p:sldId id="279" r:id="rId25"/>
     <p:sldId id="280" r:id="rId26"/>
     <p:sldId id="281" r:id="rId27"/>
+    <p:sldId id="282" r:id="rId28"/>
   </p:sldIdLst>
   <p:notesMasterIdLst>
-    <p:notesMasterId r:id="rId28"/>
+    <p:notesMasterId r:id="rId29"/>
   </p:notesMasterIdLst>
   <p:sldSz cx="12188952" cy="6858000"/>
   <p:notesSz cx="6858000" cy="12188952"/>
@@ -1730,7 +1731,7 @@
           <a:lstStyle/>
           <a:p>
             <a:r>
-              <a:t>בתרגול, 45 דקות, נעשה שלושה דברים פשוטים. נירשם לשני כלי AI חינמיים. נריץ את אותו פרומפט בדיוק בשניהם. ונתעד מה עבד, מה לא, ומה הבנו. המטרה אינה 'לבנות משהו גדול' אלא לחוות בפועל את ההבדל בין כלים, ולתרגל את עקרון הביקורת. כל מה שצריך הוא חשבון חינמי ודפדפן — אין התקנות מסובכות. בשקפים הבאים המשימה המדויקת, כולל הפרומפט וקריטריוני ההצלחה, כך שתוכלו לבצע את התרגול באופן עצמאי.</a:t>
+              <a:t>לפני שמתחילים, הנה תוכנית התרגול ל-45 דקות. חמישה שלבים: 5 דקות הקמה (בחירת שני כלים חינמיים והתחברות); 8 דקות ניסוי א' — אותו פרומפט בשני כלים שונים והשוואה; 14 דקות ניסוי ב', הלב של התרגול — אותו פרומפט פעם בעברית ופעם באנגלית, כדי לבדוק אם יש הבדל; 10 דקות אימות בהרצה בפועל, כולל בדיקת מקרה קצה של רשימה ריקה; ו-8 דקות לכתיבת דוח קצר. כל הפרומפטים המדויקים מופיעים בשקפים הבאים, כך שאפשר לעבוד באופן עצמאי. כל מה שצריך: חשבון חינמי ודפדפן.</a:t>
             </a:r>
           </a:p>
         </p:txBody>
@@ -1816,7 +1817,7 @@
           <a:lstStyle/>
           <a:p>
             <a:r>
-              <a:t>המשימה במילים פשוטות: לבד או בזוגות, הירשמו לשני כלי AI חינמיים, הריצו בשניהם את אותו פרומפט, והשוו את התוצאות. מה שמעניין אותנו אינו רק 'איזה קוד יצא' אלא ההבדלים בין הכלים: אחד אולי יסביר יותר, שני אולי יטפל במקרי קצה, שלישי אולי יטעה. בחרו שני כלים כרצונכם מהרשימה — למשל Claude.ai ו-ChatGPT לשני צ'אטים, או צ'אט מול כלי IDE. אין חובה דווקא באלה שבשקף; כל כלי חינמי מתאים. בשקף הבא הפרומפט המדויק והצעדים.</a:t>
+              <a:t>ניסוי א' — כלי מול כלי. קחו את הפרומפט שבשקף (בעברית) והריצו אותו בשני הכלים שבחרתם. קראו את שתי התשובות והשוו לפי שלוש שאלות: מי הסביר טוב יותר? מי טיפל במקרה הקצה של רשימה ריקה? והאם יש הבדל בקוד עצמו — שמות משתנים, מבנה, או הערות? המטרה כאן היא לחוות שכלים שונים נותנים תשובות שונות לאותה בקשה — ולכן בחירת הכלי משנה. שימו לב אם אחד הכלים הוסיף טיפול במקרה הקצה גם בלי שביקשתם, והשני לא.</a:t>
             </a:r>
           </a:p>
         </p:txBody>
@@ -1902,7 +1903,7 @@
           <a:lstStyle/>
           <a:p>
             <a:r>
-              <a:t>הנה התרגול צעד-אחר-צעד, כך שתוכלו לבצע לבד. שלב 1: בחרו שני כלים חינמיים מהרשימה. שלב 2: הירשמו לכל אחד — חשבון חינמי עם כתובת דוא"ל. שלב 3: הריצו בשני הכלים את הפרומפט שבתיבה השחורה: 'כתוב פונקציה בפייתון שמקבלת רשימת מספרים ומחזירה את הממוצע, הוסף טיפול ברשימה ריקה, והסבר בעברית מה הקוד עושה'. שימו לב שהפרומפט מבקש במפורש גם טיפול במקרה קצה וגם הסבר — זה פרומפט טוב. שלב 4: קראו את שתי התשובות והריצו את הקוד בפועל, למשל בסביבה חינמית כמו Google Colab. שלב 5: שאלו את עצמכם — האם הקוד באמת מטפל ברשימה ריקה, והאם הבנתם כל שורה. אלה בדיוק שתי החובות שדיברנו עליהן.</a:t>
+              <a:t>ניסוי ב' הוא הלב של התרגול — האם יש הבדל בין עברית לאנגלית? קחו את אותה משימה בדיוק והריצו אותה פעמיים באותו כלי: פעם עם הפרומפט בעברית, ופעם עם הפרומפט באנגלית (שניהם על השקף). עכשיו השוו לפי הרשימה: האם הקוד זהה? מי טיפל במקרה הקצה? האם ההסבר באנגלית ארוך או מפורט יותר? באיזו שפה נכתבו ההערות בקוד? והאם באופן כללי אחת השפות נתנה תוצאה טובה יותר? רקע חשוב: מודלים רבים אומנו בעיקר על טקסט וקוד באנגלית, ולכן לפעמים אנגלית מניבה תשובות מעט מדויקות או מפורטות יותר — אבל זה לא מובטח, ומשתנה בין כלים ומשימות. המטרה שלכם היא לבדוק בפועל ולגבש דעה מבוססת-ראיות, לא להניח מראש. זו מיומנות מעשית: כשעובדים על משימה חשובה, שווה לנסות גם באנגלית ולראות אם התוצאה משתפרת.</a:t>
             </a:r>
           </a:p>
         </p:txBody>
@@ -1988,7 +1989,7 @@
           <a:lstStyle/>
           <a:p>
             <a:r>
-              <a:t>מה נחשב הצלחה, ומה מגישים. הצלחתם אם: הרצתם את הפרומפט בשני כלים, הרצתם בפועל את הקוד שקיבלתם (לא רק קראתם), וזיהיתם לפחות הבדל אחד משמעותי בין הכלים. התוצר להגשה הוא דוח קצר, כחצי עמוד: באילו כלים השתמשתם, מה עבד, מה לא, ואיזה קוד הבנתם לעומת קוד שלא הבנתם. ההכנות לגבי 'מה לא הבנתי' חשובה כאן יותר מ'הכול עבד' — כי המטרה היא ללמוד. למי שרוצה אתגר, בונוס: בקשו מכל כלי לכתוב טסט אחד לפונקציה, ובדקו אם הטסט תפס את מקרה הרשימה הריקה. ומעל הכול — זכרו את כלל האצבע: אל תגישו קוד שלא הבנתם.</a:t>
+              <a:t>אימות בהרצה — כאן מיישמים את 'שלב 3' מהתהליך, הביקורת האנושית. פתחו את Google Colab (חינמי, בדפדפן). הריצו את הקוד שקיבלתם פעמיים: קודם עם רשימה רגילה כמו [10, 20, 30] — אמורים לקבל 20. אחר כך עם רשימה ריקה [] — וכאן ההבדל: קוד שלא טיפל במקרה הקצה ייפול בשגיאת חלוקה באפס, וקוד שכן טיפל יחזיר תשובה תקינה. רשמו לעצמכם איזה מהפלטים שקיבלתם מהכלים נפל, ואיזה שרד. זו בדיוק הסיבה שאסור לסמוך על קוד בלי להריץ אותו — הבעיה מתגלה רק בהרצה, לא בקריאה.</a:t>
             </a:r>
           </a:p>
         </p:txBody>
@@ -2074,7 +2075,7 @@
           <a:lstStyle/>
           <a:p>
             <a:r>
-              <a:t>סיימנו את מפגש 1. בנינו את התשתית: מה זה Vibe Coding, איך עובד המנוע, ומהו היחס האחראי לכלי. במפגש הבא — מפגש 2 — נצלול פנימה: איך מודל שפה 'חושב' קוד, מה זה טוקנים וחלון הקשר, ולמה בדיוק קורות הזיות ומתי הן צפויות יותר. ההבנה הזו תיתן לכם אינטואיציה מתי לסמוך על הכלי ומתי להיזהר במיוחד. נתראה במפגש 2.</a:t>
+              <a:t>לסיום, מה מגישים. הצלחתם אם עשיתם שלושה דברים: הרצתם את הפרומפט בשני כלים שונים; השוויתם בין הגרסה העברית לאנגלית; והרצתם את הקוד בפועל, כולל בדיקת רשימה ריקה. התוצר הוא דוח קצר, כחצי עמוד, שכולל: באילו כלים השתמשתם; מה היו ההבדלים בין הכלים; מה היה ההבדל בין עברית לאנגלית אם היה — לנקודה הזו אני רוצה שתתייחסו במפורש; ומי מהפלטים טיפל נכון במקרה הקצה. בונוס למתקדמים: בקשו מכל כלי לכתוב טסט אחד לפונקציה, ובדקו אם הטסט תופס את מקרה הרשימה הריקה. ומעל הכול — זכרו את כלל האצבע: אל תגישו קוד שלא הבנתם.</a:t>
             </a:r>
           </a:p>
         </p:txBody>
@@ -2097,6 +2098,92 @@
             <a:fld id="{F7021451-1387-4CA6-816F-3879F97B5CBC}" type="slidenum">
               <a:rPr lang="en-US"/>
               <a:t>26</a:t>
+            </a:fld>
+            <a:endParaRPr lang="en-US"/>
+          </a:p>
+        </p:txBody>
+      </p:sp>
+    </p:spTree>
+    <p:extLst>
+      <p:ext uri="{BB962C8B-B14F-4D97-AF65-F5344CB8AC3E}">
+        <p14:creationId xmlns:p14="http://schemas.microsoft.com/office/powerpoint/2010/main" val="1024086991"/>
+      </p:ext>
+    </p:extLst>
+  </p:cSld>
+  <p:clrMapOvr>
+    <a:masterClrMapping/>
+  </p:clrMapOvr>
+</p:notes>
+</file>
+
+<file path=ppt/notesSlides/notesSlide27.xml><?xml version="1.0" encoding="utf-8"?>
+<p:notes xmlns:a="http://schemas.openxmlformats.org/drawingml/2006/main" xmlns:r="http://schemas.openxmlformats.org/officeDocument/2006/relationships" xmlns:p="http://schemas.openxmlformats.org/presentationml/2006/main">
+  <p:cSld>
+    <p:spTree>
+      <p:nvGrpSpPr>
+        <p:cNvPr id="1" name=""/>
+        <p:cNvGrpSpPr/>
+        <p:nvPr/>
+      </p:nvGrpSpPr>
+      <p:grpSpPr>
+        <a:xfrm>
+          <a:off x="0" y="0"/>
+          <a:ext cx="0" cy="0"/>
+          <a:chOff x="0" y="0"/>
+          <a:chExt cx="0" cy="0"/>
+        </a:xfrm>
+      </p:grpSpPr>
+      <p:sp>
+        <p:nvSpPr>
+          <p:cNvPr id="2" name="Slide Image Placeholder 1"/>
+          <p:cNvSpPr>
+            <a:spLocks noGrp="1" noRot="1" noChangeAspect="1"/>
+          </p:cNvSpPr>
+          <p:nvPr>
+            <p:ph type="sldImg"/>
+          </p:nvPr>
+        </p:nvSpPr>
+        <p:spPr/>
+      </p:sp>
+      <p:sp>
+        <p:nvSpPr>
+          <p:cNvPr id="3" name="Notes Placeholder 2"/>
+          <p:cNvSpPr>
+            <a:spLocks noGrp="1"/>
+          </p:cNvSpPr>
+          <p:nvPr>
+            <p:ph type="body" idx="1"/>
+          </p:nvPr>
+        </p:nvSpPr>
+        <p:spPr/>
+        <p:txBody>
+          <a:bodyPr/>
+          <a:lstStyle/>
+          <a:p>
+            <a:r>
+              <a:t>סיימנו את מפגש 1. בנינו את התשתית: מה זה Vibe Coding, איך עובד המנוע, ומהו היחס האחראי לכלי. במפגש הבא — מפגש 2 — נצלול פנימה: איך מודל שפה 'חושב' קוד, מה זה טוקנים וחלון הקשר, ולמה בדיוק קורות הזיות ומתי הן צפויות יותר. ההבנה הזו תיתן לכם אינטואיציה מתי לסמוך על הכלי ומתי להיזהר במיוחד. נתראה במפגש 2.</a:t>
+            </a:r>
+          </a:p>
+        </p:txBody>
+      </p:sp>
+      <p:sp>
+        <p:nvSpPr>
+          <p:cNvPr id="4" name="Slide Number Placeholder 3"/>
+          <p:cNvSpPr>
+            <a:spLocks noGrp="1"/>
+          </p:cNvSpPr>
+          <p:nvPr>
+            <p:ph type="sldNum" sz="quarter" idx="10"/>
+          </p:nvPr>
+        </p:nvSpPr>
+        <p:spPr/>
+        <p:txBody>
+          <a:bodyPr/>
+          <a:lstStyle/>
+          <a:p>
+            <a:fld id="{F7021451-1387-4CA6-816F-3879F97B5CBC}" type="slidenum">
+              <a:rPr lang="en-US"/>
+              <a:t>27</a:t>
             </a:fld>
             <a:endParaRPr lang="en-US"/>
           </a:p>
@@ -3237,7 +3324,7 @@
                 <a:ea typeface="Arial" pitchFamily="34" charset="-122"/>
                 <a:cs typeface="Arial" pitchFamily="34" charset="-120"/>
               </a:rPr>
-              <a:t>01 / 26</a:t>
+              <a:t>01 / 27</a:t>
             </a:r>
             <a:endParaRPr lang="en-US" sz="950" dirty="0"/>
           </a:p>
@@ -3792,7 +3879,7 @@
                 <a:ea typeface="Arial" pitchFamily="34" charset="-122"/>
                 <a:cs typeface="Arial" pitchFamily="34" charset="-120"/>
               </a:rPr>
-              <a:t>10 / 26</a:t>
+              <a:t>10 / 27</a:t>
             </a:r>
             <a:endParaRPr lang="en-US" sz="950" dirty="0"/>
           </a:p>
@@ -4494,7 +4581,7 @@
                 <a:ea typeface="Arial" pitchFamily="34" charset="-122"/>
                 <a:cs typeface="Arial" pitchFamily="34" charset="-120"/>
               </a:rPr>
-              <a:t>11 / 26</a:t>
+              <a:t>11 / 27</a:t>
             </a:r>
             <a:endParaRPr lang="en-US" sz="950" dirty="0"/>
           </a:p>
@@ -5289,7 +5376,7 @@
                 <a:ea typeface="Arial" pitchFamily="34" charset="-122"/>
                 <a:cs typeface="Arial" pitchFamily="34" charset="-120"/>
               </a:rPr>
-              <a:t>12 / 26</a:t>
+              <a:t>12 / 27</a:t>
             </a:r>
             <a:endParaRPr lang="en-US" sz="950" dirty="0"/>
           </a:p>
@@ -6025,7 +6112,7 @@
                 <a:ea typeface="Arial" pitchFamily="34" charset="-122"/>
                 <a:cs typeface="Arial" pitchFamily="34" charset="-120"/>
               </a:rPr>
-              <a:t>13 / 26</a:t>
+              <a:t>13 / 27</a:t>
             </a:r>
             <a:endParaRPr lang="en-US" sz="950" dirty="0"/>
           </a:p>
@@ -6761,7 +6848,7 @@
                 <a:ea typeface="Arial" pitchFamily="34" charset="-122"/>
                 <a:cs typeface="Arial" pitchFamily="34" charset="-120"/>
               </a:rPr>
-              <a:t>14 / 26</a:t>
+              <a:t>14 / 27</a:t>
             </a:r>
             <a:endParaRPr lang="en-US" sz="950" dirty="0"/>
           </a:p>
@@ -7445,7 +7532,7 @@
                 <a:ea typeface="Arial" pitchFamily="34" charset="-122"/>
                 <a:cs typeface="Arial" pitchFamily="34" charset="-120"/>
               </a:rPr>
-              <a:t>15 / 26</a:t>
+              <a:t>15 / 27</a:t>
             </a:r>
             <a:endParaRPr lang="en-US" sz="950" dirty="0"/>
           </a:p>
@@ -8040,7 +8127,7 @@
                 <a:ea typeface="Arial" pitchFamily="34" charset="-122"/>
                 <a:cs typeface="Arial" pitchFamily="34" charset="-120"/>
               </a:rPr>
-              <a:t>16 / 26</a:t>
+              <a:t>16 / 27</a:t>
             </a:r>
             <a:endParaRPr lang="en-US" sz="950" dirty="0"/>
           </a:p>
@@ -8911,7 +8998,7 @@
                 <a:ea typeface="Arial" pitchFamily="34" charset="-122"/>
                 <a:cs typeface="Arial" pitchFamily="34" charset="-120"/>
               </a:rPr>
-              <a:t>17 / 26</a:t>
+              <a:t>17 / 27</a:t>
             </a:r>
             <a:endParaRPr lang="en-US" sz="950" dirty="0"/>
           </a:p>
@@ -9647,7 +9734,7 @@
                 <a:ea typeface="Arial" pitchFamily="34" charset="-122"/>
                 <a:cs typeface="Arial" pitchFamily="34" charset="-120"/>
               </a:rPr>
-              <a:t>18 / 26</a:t>
+              <a:t>18 / 27</a:t>
             </a:r>
             <a:endParaRPr lang="en-US" sz="950" dirty="0"/>
           </a:p>
@@ -10203,7 +10290,7 @@
                 <a:ea typeface="Arial" pitchFamily="34" charset="-122"/>
                 <a:cs typeface="Arial" pitchFamily="34" charset="-120"/>
               </a:rPr>
-              <a:t>19 / 26</a:t>
+              <a:t>19 / 27</a:t>
             </a:r>
             <a:endParaRPr lang="en-US" sz="950" dirty="0"/>
           </a:p>
@@ -10783,7 +10870,7 @@
                 <a:ea typeface="Arial" pitchFamily="34" charset="-122"/>
                 <a:cs typeface="Arial" pitchFamily="34" charset="-120"/>
               </a:rPr>
-              <a:t>02 / 26</a:t>
+              <a:t>02 / 27</a:t>
             </a:r>
             <a:endParaRPr lang="en-US" sz="950" dirty="0"/>
           </a:p>
@@ -11805,7 +11892,7 @@
                 <a:ea typeface="Arial" pitchFamily="34" charset="-122"/>
                 <a:cs typeface="Arial" pitchFamily="34" charset="-120"/>
               </a:rPr>
-              <a:t>20 / 26</a:t>
+              <a:t>20 / 27</a:t>
             </a:r>
             <a:endParaRPr lang="en-US" sz="950" dirty="0"/>
           </a:p>
@@ -12483,7 +12570,7 @@
                 <a:ea typeface="Arial" pitchFamily="34" charset="-122"/>
                 <a:cs typeface="Arial" pitchFamily="34" charset="-120"/>
               </a:rPr>
-              <a:t>21 / 26</a:t>
+              <a:t>21 / 27</a:t>
             </a:r>
             <a:endParaRPr lang="en-US" sz="950" dirty="0"/>
           </a:p>
@@ -12632,7 +12719,7 @@
                 <a:ea typeface="Arial" pitchFamily="34" charset="-122"/>
                 <a:cs typeface="Arial" pitchFamily="34" charset="-120"/>
               </a:rPr>
-              <a:t>מה נעשה בתרגול (45 דקות)</a:t>
+              <a:t>תוכנית התרגול — 45 דקות</a:t>
             </a:r>
             <a:endParaRPr lang="en-US" sz="3300" dirty="0"/>
           </a:p>
@@ -12646,310 +12733,16 @@
         </p:nvSpPr>
         <p:spPr>
           <a:xfrm>
-            <a:off x="11137392" y="1874520"/>
-            <a:ext cx="502920" cy="502920"/>
-          </a:xfrm>
-          <a:prstGeom prst="ellipse">
-            <a:avLst/>
-          </a:prstGeom>
-          <a:solidFill>
-            <a:srgbClr val="0E9AA7"/>
-          </a:solidFill>
-          <a:ln/>
-        </p:spPr>
-      </p:sp>
-      <p:sp>
-        <p:nvSpPr>
-          <p:cNvPr id="5" name="Text 3"/>
-          <p:cNvSpPr/>
-          <p:nvPr/>
-        </p:nvSpPr>
-        <p:spPr>
-          <a:xfrm>
-            <a:off x="11137392" y="1874520"/>
-            <a:ext cx="502920" cy="502920"/>
-          </a:xfrm>
-          <a:prstGeom prst="rect">
-            <a:avLst/>
-          </a:prstGeom>
-          <a:noFill/>
-          <a:ln/>
-        </p:spPr>
-        <p:txBody>
-          <a:bodyPr wrap="square" rtlCol="0" anchor="ctr"/>
-          <a:lstStyle/>
-          <a:p>
-            <a:pPr algn="ctr" indent="0" marL="0">
-              <a:buNone/>
-            </a:pPr>
-            <a:r>
-              <a:rPr lang="en-US" sz="1600" b="1" dirty="0">
-                <a:solidFill>
-                  <a:srgbClr val="FFFFFF"/>
-                </a:solidFill>
-                <a:latin typeface="Arial" pitchFamily="34" charset="0"/>
-                <a:ea typeface="Arial" pitchFamily="34" charset="-122"/>
-                <a:cs typeface="Arial" pitchFamily="34" charset="-120"/>
-              </a:rPr>
-              <a:t>1</a:t>
-            </a:r>
-            <a:endParaRPr lang="en-US" sz="1600" dirty="0"/>
-          </a:p>
-        </p:txBody>
-      </p:sp>
-      <p:sp>
-        <p:nvSpPr>
-          <p:cNvPr id="6" name="Text 4"/>
-          <p:cNvSpPr/>
-          <p:nvPr/>
-        </p:nvSpPr>
-        <p:spPr>
-          <a:xfrm>
-            <a:off x="548640" y="1856232"/>
-            <a:ext cx="10424160" cy="384048"/>
-          </a:xfrm>
-          <a:prstGeom prst="rect">
-            <a:avLst/>
-          </a:prstGeom>
-          <a:noFill/>
-          <a:ln/>
-        </p:spPr>
-        <p:txBody>
-          <a:bodyPr wrap="square" rtlCol="0" anchor="t"/>
-          <a:lstStyle/>
-          <a:p>
-            <a:pPr rtl="1" algn="r" indent="0" marL="0">
-              <a:buNone/>
-            </a:pPr>
-            <a:r>
-              <a:rPr lang="en-US" sz="1700" b="1" dirty="0">
-                <a:solidFill>
-                  <a:srgbClr val="222232"/>
-                </a:solidFill>
-                <a:latin typeface="Arial" pitchFamily="34" charset="0"/>
-                <a:ea typeface="Arial" pitchFamily="34" charset="-122"/>
-                <a:cs typeface="Arial" pitchFamily="34" charset="-120"/>
-              </a:rPr>
-              <a:t>נירשם ל-2 כלי AI חינמיים.</a:t>
-            </a:r>
-            <a:endParaRPr lang="en-US" sz="1700" dirty="0"/>
-          </a:p>
-        </p:txBody>
-      </p:sp>
-      <p:sp>
-        <p:nvSpPr>
-          <p:cNvPr id="7" name="Shape 5"/>
-          <p:cNvSpPr/>
-          <p:nvPr/>
-        </p:nvSpPr>
-        <p:spPr>
-          <a:xfrm>
-            <a:off x="11137392" y="2743200"/>
-            <a:ext cx="502920" cy="502920"/>
-          </a:xfrm>
-          <a:prstGeom prst="ellipse">
-            <a:avLst/>
-          </a:prstGeom>
-          <a:solidFill>
-            <a:srgbClr val="0E9AA7"/>
-          </a:solidFill>
-          <a:ln/>
-        </p:spPr>
-      </p:sp>
-      <p:sp>
-        <p:nvSpPr>
-          <p:cNvPr id="8" name="Text 6"/>
-          <p:cNvSpPr/>
-          <p:nvPr/>
-        </p:nvSpPr>
-        <p:spPr>
-          <a:xfrm>
-            <a:off x="11137392" y="2743200"/>
-            <a:ext cx="502920" cy="502920"/>
-          </a:xfrm>
-          <a:prstGeom prst="rect">
-            <a:avLst/>
-          </a:prstGeom>
-          <a:noFill/>
-          <a:ln/>
-        </p:spPr>
-        <p:txBody>
-          <a:bodyPr wrap="square" rtlCol="0" anchor="ctr"/>
-          <a:lstStyle/>
-          <a:p>
-            <a:pPr algn="ctr" indent="0" marL="0">
-              <a:buNone/>
-            </a:pPr>
-            <a:r>
-              <a:rPr lang="en-US" sz="1600" b="1" dirty="0">
-                <a:solidFill>
-                  <a:srgbClr val="FFFFFF"/>
-                </a:solidFill>
-                <a:latin typeface="Arial" pitchFamily="34" charset="0"/>
-                <a:ea typeface="Arial" pitchFamily="34" charset="-122"/>
-                <a:cs typeface="Arial" pitchFamily="34" charset="-120"/>
-              </a:rPr>
-              <a:t>2</a:t>
-            </a:r>
-            <a:endParaRPr lang="en-US" sz="1600" dirty="0"/>
-          </a:p>
-        </p:txBody>
-      </p:sp>
-      <p:sp>
-        <p:nvSpPr>
-          <p:cNvPr id="9" name="Text 7"/>
-          <p:cNvSpPr/>
-          <p:nvPr/>
-        </p:nvSpPr>
-        <p:spPr>
-          <a:xfrm>
-            <a:off x="548640" y="2724912"/>
-            <a:ext cx="10424160" cy="384048"/>
-          </a:xfrm>
-          <a:prstGeom prst="rect">
-            <a:avLst/>
-          </a:prstGeom>
-          <a:noFill/>
-          <a:ln/>
-        </p:spPr>
-        <p:txBody>
-          <a:bodyPr wrap="square" rtlCol="0" anchor="t"/>
-          <a:lstStyle/>
-          <a:p>
-            <a:pPr rtl="1" algn="r" indent="0" marL="0">
-              <a:buNone/>
-            </a:pPr>
-            <a:r>
-              <a:rPr lang="en-US" sz="1700" b="1" dirty="0">
-                <a:solidFill>
-                  <a:srgbClr val="222232"/>
-                </a:solidFill>
-                <a:latin typeface="Arial" pitchFamily="34" charset="0"/>
-                <a:ea typeface="Arial" pitchFamily="34" charset="-122"/>
-                <a:cs typeface="Arial" pitchFamily="34" charset="-120"/>
-              </a:rPr>
-              <a:t>נריץ את אותו פרומפט בשניהם — ונשווה.</a:t>
-            </a:r>
-            <a:endParaRPr lang="en-US" sz="1700" dirty="0"/>
-          </a:p>
-        </p:txBody>
-      </p:sp>
-      <p:sp>
-        <p:nvSpPr>
-          <p:cNvPr id="10" name="Shape 8"/>
-          <p:cNvSpPr/>
-          <p:nvPr/>
-        </p:nvSpPr>
-        <p:spPr>
-          <a:xfrm>
-            <a:off x="11137392" y="3611880"/>
-            <a:ext cx="502920" cy="502920"/>
-          </a:xfrm>
-          <a:prstGeom prst="ellipse">
-            <a:avLst/>
-          </a:prstGeom>
-          <a:solidFill>
-            <a:srgbClr val="0E9AA7"/>
-          </a:solidFill>
-          <a:ln/>
-        </p:spPr>
-      </p:sp>
-      <p:sp>
-        <p:nvSpPr>
-          <p:cNvPr id="11" name="Text 9"/>
-          <p:cNvSpPr/>
-          <p:nvPr/>
-        </p:nvSpPr>
-        <p:spPr>
-          <a:xfrm>
-            <a:off x="11137392" y="3611880"/>
-            <a:ext cx="502920" cy="502920"/>
-          </a:xfrm>
-          <a:prstGeom prst="rect">
-            <a:avLst/>
-          </a:prstGeom>
-          <a:noFill/>
-          <a:ln/>
-        </p:spPr>
-        <p:txBody>
-          <a:bodyPr wrap="square" rtlCol="0" anchor="ctr"/>
-          <a:lstStyle/>
-          <a:p>
-            <a:pPr algn="ctr" indent="0" marL="0">
-              <a:buNone/>
-            </a:pPr>
-            <a:r>
-              <a:rPr lang="en-US" sz="1600" b="1" dirty="0">
-                <a:solidFill>
-                  <a:srgbClr val="FFFFFF"/>
-                </a:solidFill>
-                <a:latin typeface="Arial" pitchFamily="34" charset="0"/>
-                <a:ea typeface="Arial" pitchFamily="34" charset="-122"/>
-                <a:cs typeface="Arial" pitchFamily="34" charset="-120"/>
-              </a:rPr>
-              <a:t>3</a:t>
-            </a:r>
-            <a:endParaRPr lang="en-US" sz="1600" dirty="0"/>
-          </a:p>
-        </p:txBody>
-      </p:sp>
-      <p:sp>
-        <p:nvSpPr>
-          <p:cNvPr id="12" name="Text 10"/>
-          <p:cNvSpPr/>
-          <p:nvPr/>
-        </p:nvSpPr>
-        <p:spPr>
-          <a:xfrm>
-            <a:off x="548640" y="3593592"/>
-            <a:ext cx="10424160" cy="384048"/>
-          </a:xfrm>
-          <a:prstGeom prst="rect">
-            <a:avLst/>
-          </a:prstGeom>
-          <a:noFill/>
-          <a:ln/>
-        </p:spPr>
-        <p:txBody>
-          <a:bodyPr wrap="square" rtlCol="0" anchor="t"/>
-          <a:lstStyle/>
-          <a:p>
-            <a:pPr rtl="1" algn="r" indent="0" marL="0">
-              <a:buNone/>
-            </a:pPr>
-            <a:r>
-              <a:rPr lang="en-US" sz="1700" b="1" dirty="0">
-                <a:solidFill>
-                  <a:srgbClr val="222232"/>
-                </a:solidFill>
-                <a:latin typeface="Arial" pitchFamily="34" charset="0"/>
-                <a:ea typeface="Arial" pitchFamily="34" charset="-122"/>
-                <a:cs typeface="Arial" pitchFamily="34" charset="-120"/>
-              </a:rPr>
-              <a:t>נתעד: מה עבד, מה לא, ומה הבנו.</a:t>
-            </a:r>
-            <a:endParaRPr lang="en-US" sz="1700" dirty="0"/>
-          </a:p>
-        </p:txBody>
-      </p:sp>
-      <p:sp>
-        <p:nvSpPr>
-          <p:cNvPr id="13" name="Shape 11"/>
-          <p:cNvSpPr/>
-          <p:nvPr/>
-        </p:nvSpPr>
-        <p:spPr>
-          <a:xfrm>
-            <a:off x="548640" y="4709160"/>
-            <a:ext cx="11091672" cy="868680"/>
+            <a:off x="2011680" y="1691640"/>
+            <a:ext cx="9628632" cy="621792"/>
           </a:xfrm>
           <a:prstGeom prst="roundRect">
             <a:avLst>
-              <a:gd name="adj" fmla="val 10526"/>
+              <a:gd name="adj" fmla="val 13235"/>
             </a:avLst>
           </a:prstGeom>
           <a:solidFill>
-            <a:srgbClr val="1E2761"/>
+            <a:srgbClr val="F2F3FA"/>
           </a:solidFill>
           <a:ln/>
           <a:effectLst>
@@ -12963,14 +12756,14 @@
       </p:sp>
       <p:sp>
         <p:nvSpPr>
-          <p:cNvPr id="14" name="Text 12"/>
-          <p:cNvSpPr/>
-          <p:nvPr/>
-        </p:nvSpPr>
-        <p:spPr>
-          <a:xfrm>
-            <a:off x="868680" y="4892040"/>
-            <a:ext cx="10451592" cy="502920"/>
+          <p:cNvPr id="5" name="Text 3"/>
+          <p:cNvSpPr/>
+          <p:nvPr/>
+        </p:nvSpPr>
+        <p:spPr>
+          <a:xfrm>
+            <a:off x="2240280" y="1691640"/>
+            <a:ext cx="9125712" cy="621792"/>
           </a:xfrm>
           <a:prstGeom prst="rect">
             <a:avLst/>
@@ -12988,13 +12781,142 @@
             <a:r>
               <a:rPr lang="en-US" sz="1600" b="1" dirty="0">
                 <a:solidFill>
+                  <a:srgbClr val="222232"/>
+                </a:solidFill>
+                <a:latin typeface="Arial" pitchFamily="34" charset="0"/>
+                <a:ea typeface="Arial" pitchFamily="34" charset="-122"/>
+                <a:cs typeface="Arial" pitchFamily="34" charset="-120"/>
+              </a:rPr>
+              <a:t>הקמה · בחירת 2 כלים + כניסה</a:t>
+            </a:r>
+            <a:endParaRPr lang="en-US" sz="1600" dirty="0"/>
+          </a:p>
+        </p:txBody>
+      </p:sp>
+      <p:sp>
+        <p:nvSpPr>
+          <p:cNvPr id="6" name="Shape 4"/>
+          <p:cNvSpPr/>
+          <p:nvPr/>
+        </p:nvSpPr>
+        <p:spPr>
+          <a:xfrm>
+            <a:off x="548640" y="1691640"/>
+            <a:ext cx="1280160" cy="621792"/>
+          </a:xfrm>
+          <a:prstGeom prst="roundRect">
+            <a:avLst>
+              <a:gd name="adj" fmla="val 11765"/>
+            </a:avLst>
+          </a:prstGeom>
+          <a:solidFill>
+            <a:srgbClr val="3B3B98"/>
+          </a:solidFill>
+          <a:ln/>
+        </p:spPr>
+      </p:sp>
+      <p:sp>
+        <p:nvSpPr>
+          <p:cNvPr id="7" name="Text 5"/>
+          <p:cNvSpPr/>
+          <p:nvPr/>
+        </p:nvSpPr>
+        <p:spPr>
+          <a:xfrm>
+            <a:off x="548640" y="1691640"/>
+            <a:ext cx="1280160" cy="621792"/>
+          </a:xfrm>
+          <a:prstGeom prst="rect">
+            <a:avLst/>
+          </a:prstGeom>
+          <a:noFill/>
+          <a:ln/>
+        </p:spPr>
+        <p:txBody>
+          <a:bodyPr wrap="square" rtlCol="0" anchor="ctr"/>
+          <a:lstStyle/>
+          <a:p>
+            <a:pPr rtl="1" algn="ctr" indent="0" marL="0">
+              <a:buNone/>
+            </a:pPr>
+            <a:r>
+              <a:rPr lang="en-US" sz="1500" b="1" dirty="0">
+                <a:solidFill>
                   <a:srgbClr val="FFFFFF"/>
                 </a:solidFill>
                 <a:latin typeface="Arial" pitchFamily="34" charset="0"/>
                 <a:ea typeface="Arial" pitchFamily="34" charset="-122"/>
                 <a:cs typeface="Arial" pitchFamily="34" charset="-120"/>
               </a:rPr>
-              <a:t>מה צריך: חשבון חינמי + דפדפן. אין צורך בהתקנות מיוחדות.</a:t>
+              <a:t>5 דק'</a:t>
+            </a:r>
+            <a:endParaRPr lang="en-US" sz="1500" dirty="0"/>
+          </a:p>
+        </p:txBody>
+      </p:sp>
+      <p:sp>
+        <p:nvSpPr>
+          <p:cNvPr id="8" name="Shape 6"/>
+          <p:cNvSpPr/>
+          <p:nvPr/>
+        </p:nvSpPr>
+        <p:spPr>
+          <a:xfrm>
+            <a:off x="2011680" y="2441448"/>
+            <a:ext cx="9628632" cy="621792"/>
+          </a:xfrm>
+          <a:prstGeom prst="roundRect">
+            <a:avLst>
+              <a:gd name="adj" fmla="val 13235"/>
+            </a:avLst>
+          </a:prstGeom>
+          <a:solidFill>
+            <a:srgbClr val="F2F3FA"/>
+          </a:solidFill>
+          <a:ln/>
+          <a:effectLst>
+            <a:outerShdw sx="100000" sy="100000" kx="0" ky="0" algn="bl" rotWithShape="0" blurRad="76200" dist="25400" dir="5400000">
+              <a:srgbClr val="999999">
+                <a:alpha val="28000"/>
+              </a:srgbClr>
+            </a:outerShdw>
+          </a:effectLst>
+        </p:spPr>
+      </p:sp>
+      <p:sp>
+        <p:nvSpPr>
+          <p:cNvPr id="9" name="Text 7"/>
+          <p:cNvSpPr/>
+          <p:nvPr/>
+        </p:nvSpPr>
+        <p:spPr>
+          <a:xfrm>
+            <a:off x="2240280" y="2441448"/>
+            <a:ext cx="9125712" cy="621792"/>
+          </a:xfrm>
+          <a:prstGeom prst="rect">
+            <a:avLst/>
+          </a:prstGeom>
+          <a:noFill/>
+          <a:ln/>
+        </p:spPr>
+        <p:txBody>
+          <a:bodyPr wrap="square" rtlCol="0" anchor="ctr"/>
+          <a:lstStyle/>
+          <a:p>
+            <a:pPr rtl="1" algn="r" indent="0" marL="0">
+              <a:buNone/>
+            </a:pPr>
+            <a:r>
+              <a:rPr lang="en-US" sz="1600" b="1" dirty="0">
+                <a:solidFill>
+                  <a:srgbClr val="222232"/>
+                </a:solidFill>
+                <a:latin typeface="Arial" pitchFamily="34" charset="0"/>
+                <a:ea typeface="Arial" pitchFamily="34" charset="-122"/>
+                <a:cs typeface="Arial" pitchFamily="34" charset="-120"/>
+              </a:rPr>
+              <a:t>ניסוי א' · כלי מול כלי</a:t>
             </a:r>
             <a:endParaRPr lang="en-US" sz="1600" dirty="0"/>
           </a:p>
@@ -13002,7 +12924,494 @@
       </p:sp>
       <p:sp>
         <p:nvSpPr>
+          <p:cNvPr id="10" name="Shape 8"/>
+          <p:cNvSpPr/>
+          <p:nvPr/>
+        </p:nvSpPr>
+        <p:spPr>
+          <a:xfrm>
+            <a:off x="548640" y="2441448"/>
+            <a:ext cx="1280160" cy="621792"/>
+          </a:xfrm>
+          <a:prstGeom prst="roundRect">
+            <a:avLst>
+              <a:gd name="adj" fmla="val 11765"/>
+            </a:avLst>
+          </a:prstGeom>
+          <a:solidFill>
+            <a:srgbClr val="3B3B98"/>
+          </a:solidFill>
+          <a:ln/>
+        </p:spPr>
+      </p:sp>
+      <p:sp>
+        <p:nvSpPr>
+          <p:cNvPr id="11" name="Text 9"/>
+          <p:cNvSpPr/>
+          <p:nvPr/>
+        </p:nvSpPr>
+        <p:spPr>
+          <a:xfrm>
+            <a:off x="548640" y="2441448"/>
+            <a:ext cx="1280160" cy="621792"/>
+          </a:xfrm>
+          <a:prstGeom prst="rect">
+            <a:avLst/>
+          </a:prstGeom>
+          <a:noFill/>
+          <a:ln/>
+        </p:spPr>
+        <p:txBody>
+          <a:bodyPr wrap="square" rtlCol="0" anchor="ctr"/>
+          <a:lstStyle/>
+          <a:p>
+            <a:pPr rtl="1" algn="ctr" indent="0" marL="0">
+              <a:buNone/>
+            </a:pPr>
+            <a:r>
+              <a:rPr lang="en-US" sz="1500" b="1" dirty="0">
+                <a:solidFill>
+                  <a:srgbClr val="FFFFFF"/>
+                </a:solidFill>
+                <a:latin typeface="Arial" pitchFamily="34" charset="0"/>
+                <a:ea typeface="Arial" pitchFamily="34" charset="-122"/>
+                <a:cs typeface="Arial" pitchFamily="34" charset="-120"/>
+              </a:rPr>
+              <a:t>8 דק'</a:t>
+            </a:r>
+            <a:endParaRPr lang="en-US" sz="1500" dirty="0"/>
+          </a:p>
+        </p:txBody>
+      </p:sp>
+      <p:sp>
+        <p:nvSpPr>
+          <p:cNvPr id="12" name="Shape 10"/>
+          <p:cNvSpPr/>
+          <p:nvPr/>
+        </p:nvSpPr>
+        <p:spPr>
+          <a:xfrm>
+            <a:off x="2011680" y="3191256"/>
+            <a:ext cx="9628632" cy="621792"/>
+          </a:xfrm>
+          <a:prstGeom prst="roundRect">
+            <a:avLst>
+              <a:gd name="adj" fmla="val 13235"/>
+            </a:avLst>
+          </a:prstGeom>
+          <a:solidFill>
+            <a:srgbClr val="E7F5F6"/>
+          </a:solidFill>
+          <a:ln/>
+          <a:effectLst>
+            <a:outerShdw sx="100000" sy="100000" kx="0" ky="0" algn="bl" rotWithShape="0" blurRad="76200" dist="25400" dir="5400000">
+              <a:srgbClr val="999999">
+                <a:alpha val="28000"/>
+              </a:srgbClr>
+            </a:outerShdw>
+          </a:effectLst>
+        </p:spPr>
+      </p:sp>
+      <p:sp>
+        <p:nvSpPr>
+          <p:cNvPr id="13" name="Text 11"/>
+          <p:cNvSpPr/>
+          <p:nvPr/>
+        </p:nvSpPr>
+        <p:spPr>
+          <a:xfrm>
+            <a:off x="2240280" y="3191256"/>
+            <a:ext cx="9125712" cy="621792"/>
+          </a:xfrm>
+          <a:prstGeom prst="rect">
+            <a:avLst/>
+          </a:prstGeom>
+          <a:noFill/>
+          <a:ln/>
+        </p:spPr>
+        <p:txBody>
+          <a:bodyPr wrap="square" rtlCol="0" anchor="ctr"/>
+          <a:lstStyle/>
+          <a:p>
+            <a:pPr rtl="1" algn="r" indent="0" marL="0">
+              <a:buNone/>
+            </a:pPr>
+            <a:r>
+              <a:rPr lang="en-US" sz="1600" b="1" dirty="0">
+                <a:solidFill>
+                  <a:srgbClr val="222232"/>
+                </a:solidFill>
+                <a:latin typeface="Arial" pitchFamily="34" charset="0"/>
+                <a:ea typeface="Arial" pitchFamily="34" charset="-122"/>
+                <a:cs typeface="Arial" pitchFamily="34" charset="-120"/>
+              </a:rPr>
+              <a:t>ניסוי ב' · עברית מול אנגלית</a:t>
+            </a:r>
+            <a:endParaRPr lang="en-US" sz="1600" dirty="0"/>
+          </a:p>
+        </p:txBody>
+      </p:sp>
+      <p:sp>
+        <p:nvSpPr>
+          <p:cNvPr id="14" name="Shape 12"/>
+          <p:cNvSpPr/>
+          <p:nvPr/>
+        </p:nvSpPr>
+        <p:spPr>
+          <a:xfrm>
+            <a:off x="548640" y="3191256"/>
+            <a:ext cx="1280160" cy="621792"/>
+          </a:xfrm>
+          <a:prstGeom prst="roundRect">
+            <a:avLst>
+              <a:gd name="adj" fmla="val 11765"/>
+            </a:avLst>
+          </a:prstGeom>
+          <a:solidFill>
+            <a:srgbClr val="0E9AA7"/>
+          </a:solidFill>
+          <a:ln/>
+        </p:spPr>
+      </p:sp>
+      <p:sp>
+        <p:nvSpPr>
           <p:cNvPr id="15" name="Text 13"/>
+          <p:cNvSpPr/>
+          <p:nvPr/>
+        </p:nvSpPr>
+        <p:spPr>
+          <a:xfrm>
+            <a:off x="548640" y="3191256"/>
+            <a:ext cx="1280160" cy="621792"/>
+          </a:xfrm>
+          <a:prstGeom prst="rect">
+            <a:avLst/>
+          </a:prstGeom>
+          <a:noFill/>
+          <a:ln/>
+        </p:spPr>
+        <p:txBody>
+          <a:bodyPr wrap="square" rtlCol="0" anchor="ctr"/>
+          <a:lstStyle/>
+          <a:p>
+            <a:pPr rtl="1" algn="ctr" indent="0" marL="0">
+              <a:buNone/>
+            </a:pPr>
+            <a:r>
+              <a:rPr lang="en-US" sz="1500" b="1" dirty="0">
+                <a:solidFill>
+                  <a:srgbClr val="FFFFFF"/>
+                </a:solidFill>
+                <a:latin typeface="Arial" pitchFamily="34" charset="0"/>
+                <a:ea typeface="Arial" pitchFamily="34" charset="-122"/>
+                <a:cs typeface="Arial" pitchFamily="34" charset="-120"/>
+              </a:rPr>
+              <a:t>14 דק'</a:t>
+            </a:r>
+            <a:endParaRPr lang="en-US" sz="1500" dirty="0"/>
+          </a:p>
+        </p:txBody>
+      </p:sp>
+      <p:sp>
+        <p:nvSpPr>
+          <p:cNvPr id="16" name="Shape 14"/>
+          <p:cNvSpPr/>
+          <p:nvPr/>
+        </p:nvSpPr>
+        <p:spPr>
+          <a:xfrm>
+            <a:off x="2011680" y="3941064"/>
+            <a:ext cx="9628632" cy="621792"/>
+          </a:xfrm>
+          <a:prstGeom prst="roundRect">
+            <a:avLst>
+              <a:gd name="adj" fmla="val 13235"/>
+            </a:avLst>
+          </a:prstGeom>
+          <a:solidFill>
+            <a:srgbClr val="F2F3FA"/>
+          </a:solidFill>
+          <a:ln/>
+          <a:effectLst>
+            <a:outerShdw sx="100000" sy="100000" kx="0" ky="0" algn="bl" rotWithShape="0" blurRad="76200" dist="25400" dir="5400000">
+              <a:srgbClr val="999999">
+                <a:alpha val="28000"/>
+              </a:srgbClr>
+            </a:outerShdw>
+          </a:effectLst>
+        </p:spPr>
+      </p:sp>
+      <p:sp>
+        <p:nvSpPr>
+          <p:cNvPr id="17" name="Text 15"/>
+          <p:cNvSpPr/>
+          <p:nvPr/>
+        </p:nvSpPr>
+        <p:spPr>
+          <a:xfrm>
+            <a:off x="2240280" y="3941064"/>
+            <a:ext cx="9125712" cy="621792"/>
+          </a:xfrm>
+          <a:prstGeom prst="rect">
+            <a:avLst/>
+          </a:prstGeom>
+          <a:noFill/>
+          <a:ln/>
+        </p:spPr>
+        <p:txBody>
+          <a:bodyPr wrap="square" rtlCol="0" anchor="ctr"/>
+          <a:lstStyle/>
+          <a:p>
+            <a:pPr rtl="1" algn="r" indent="0" marL="0">
+              <a:buNone/>
+            </a:pPr>
+            <a:r>
+              <a:rPr lang="en-US" sz="1600" b="1" dirty="0">
+                <a:solidFill>
+                  <a:srgbClr val="222232"/>
+                </a:solidFill>
+                <a:latin typeface="Arial" pitchFamily="34" charset="0"/>
+                <a:ea typeface="Arial" pitchFamily="34" charset="-122"/>
+                <a:cs typeface="Arial" pitchFamily="34" charset="-120"/>
+              </a:rPr>
+              <a:t>אימות בהרצה · מקרי קצה</a:t>
+            </a:r>
+            <a:endParaRPr lang="en-US" sz="1600" dirty="0"/>
+          </a:p>
+        </p:txBody>
+      </p:sp>
+      <p:sp>
+        <p:nvSpPr>
+          <p:cNvPr id="18" name="Shape 16"/>
+          <p:cNvSpPr/>
+          <p:nvPr/>
+        </p:nvSpPr>
+        <p:spPr>
+          <a:xfrm>
+            <a:off x="548640" y="3941064"/>
+            <a:ext cx="1280160" cy="621792"/>
+          </a:xfrm>
+          <a:prstGeom prst="roundRect">
+            <a:avLst>
+              <a:gd name="adj" fmla="val 11765"/>
+            </a:avLst>
+          </a:prstGeom>
+          <a:solidFill>
+            <a:srgbClr val="3B3B98"/>
+          </a:solidFill>
+          <a:ln/>
+        </p:spPr>
+      </p:sp>
+      <p:sp>
+        <p:nvSpPr>
+          <p:cNvPr id="19" name="Text 17"/>
+          <p:cNvSpPr/>
+          <p:nvPr/>
+        </p:nvSpPr>
+        <p:spPr>
+          <a:xfrm>
+            <a:off x="548640" y="3941064"/>
+            <a:ext cx="1280160" cy="621792"/>
+          </a:xfrm>
+          <a:prstGeom prst="rect">
+            <a:avLst/>
+          </a:prstGeom>
+          <a:noFill/>
+          <a:ln/>
+        </p:spPr>
+        <p:txBody>
+          <a:bodyPr wrap="square" rtlCol="0" anchor="ctr"/>
+          <a:lstStyle/>
+          <a:p>
+            <a:pPr rtl="1" algn="ctr" indent="0" marL="0">
+              <a:buNone/>
+            </a:pPr>
+            <a:r>
+              <a:rPr lang="en-US" sz="1500" b="1" dirty="0">
+                <a:solidFill>
+                  <a:srgbClr val="FFFFFF"/>
+                </a:solidFill>
+                <a:latin typeface="Arial" pitchFamily="34" charset="0"/>
+                <a:ea typeface="Arial" pitchFamily="34" charset="-122"/>
+                <a:cs typeface="Arial" pitchFamily="34" charset="-120"/>
+              </a:rPr>
+              <a:t>10 דק'</a:t>
+            </a:r>
+            <a:endParaRPr lang="en-US" sz="1500" dirty="0"/>
+          </a:p>
+        </p:txBody>
+      </p:sp>
+      <p:sp>
+        <p:nvSpPr>
+          <p:cNvPr id="20" name="Shape 18"/>
+          <p:cNvSpPr/>
+          <p:nvPr/>
+        </p:nvSpPr>
+        <p:spPr>
+          <a:xfrm>
+            <a:off x="2011680" y="4690872"/>
+            <a:ext cx="9628632" cy="621792"/>
+          </a:xfrm>
+          <a:prstGeom prst="roundRect">
+            <a:avLst>
+              <a:gd name="adj" fmla="val 13235"/>
+            </a:avLst>
+          </a:prstGeom>
+          <a:solidFill>
+            <a:srgbClr val="F2F3FA"/>
+          </a:solidFill>
+          <a:ln/>
+          <a:effectLst>
+            <a:outerShdw sx="100000" sy="100000" kx="0" ky="0" algn="bl" rotWithShape="0" blurRad="76200" dist="25400" dir="5400000">
+              <a:srgbClr val="999999">
+                <a:alpha val="28000"/>
+              </a:srgbClr>
+            </a:outerShdw>
+          </a:effectLst>
+        </p:spPr>
+      </p:sp>
+      <p:sp>
+        <p:nvSpPr>
+          <p:cNvPr id="21" name="Text 19"/>
+          <p:cNvSpPr/>
+          <p:nvPr/>
+        </p:nvSpPr>
+        <p:spPr>
+          <a:xfrm>
+            <a:off x="2240280" y="4690872"/>
+            <a:ext cx="9125712" cy="621792"/>
+          </a:xfrm>
+          <a:prstGeom prst="rect">
+            <a:avLst/>
+          </a:prstGeom>
+          <a:noFill/>
+          <a:ln/>
+        </p:spPr>
+        <p:txBody>
+          <a:bodyPr wrap="square" rtlCol="0" anchor="ctr"/>
+          <a:lstStyle/>
+          <a:p>
+            <a:pPr rtl="1" algn="r" indent="0" marL="0">
+              <a:buNone/>
+            </a:pPr>
+            <a:r>
+              <a:rPr lang="en-US" sz="1600" b="1" dirty="0">
+                <a:solidFill>
+                  <a:srgbClr val="222232"/>
+                </a:solidFill>
+                <a:latin typeface="Arial" pitchFamily="34" charset="0"/>
+                <a:ea typeface="Arial" pitchFamily="34" charset="-122"/>
+                <a:cs typeface="Arial" pitchFamily="34" charset="-120"/>
+              </a:rPr>
+              <a:t>דוח קצר · סיכום ממצאים</a:t>
+            </a:r>
+            <a:endParaRPr lang="en-US" sz="1600" dirty="0"/>
+          </a:p>
+        </p:txBody>
+      </p:sp>
+      <p:sp>
+        <p:nvSpPr>
+          <p:cNvPr id="22" name="Shape 20"/>
+          <p:cNvSpPr/>
+          <p:nvPr/>
+        </p:nvSpPr>
+        <p:spPr>
+          <a:xfrm>
+            <a:off x="548640" y="4690872"/>
+            <a:ext cx="1280160" cy="621792"/>
+          </a:xfrm>
+          <a:prstGeom prst="roundRect">
+            <a:avLst>
+              <a:gd name="adj" fmla="val 11765"/>
+            </a:avLst>
+          </a:prstGeom>
+          <a:solidFill>
+            <a:srgbClr val="3B3B98"/>
+          </a:solidFill>
+          <a:ln/>
+        </p:spPr>
+      </p:sp>
+      <p:sp>
+        <p:nvSpPr>
+          <p:cNvPr id="23" name="Text 21"/>
+          <p:cNvSpPr/>
+          <p:nvPr/>
+        </p:nvSpPr>
+        <p:spPr>
+          <a:xfrm>
+            <a:off x="548640" y="4690872"/>
+            <a:ext cx="1280160" cy="621792"/>
+          </a:xfrm>
+          <a:prstGeom prst="rect">
+            <a:avLst/>
+          </a:prstGeom>
+          <a:noFill/>
+          <a:ln/>
+        </p:spPr>
+        <p:txBody>
+          <a:bodyPr wrap="square" rtlCol="0" anchor="ctr"/>
+          <a:lstStyle/>
+          <a:p>
+            <a:pPr rtl="1" algn="ctr" indent="0" marL="0">
+              <a:buNone/>
+            </a:pPr>
+            <a:r>
+              <a:rPr lang="en-US" sz="1500" b="1" dirty="0">
+                <a:solidFill>
+                  <a:srgbClr val="FFFFFF"/>
+                </a:solidFill>
+                <a:latin typeface="Arial" pitchFamily="34" charset="0"/>
+                <a:ea typeface="Arial" pitchFamily="34" charset="-122"/>
+                <a:cs typeface="Arial" pitchFamily="34" charset="-120"/>
+              </a:rPr>
+              <a:t>8 דק'</a:t>
+            </a:r>
+            <a:endParaRPr lang="en-US" sz="1500" dirty="0"/>
+          </a:p>
+        </p:txBody>
+      </p:sp>
+      <p:sp>
+        <p:nvSpPr>
+          <p:cNvPr id="24" name="Text 22"/>
+          <p:cNvSpPr/>
+          <p:nvPr/>
+        </p:nvSpPr>
+        <p:spPr>
+          <a:xfrm>
+            <a:off x="548640" y="5532120"/>
+            <a:ext cx="11091672" cy="365760"/>
+          </a:xfrm>
+          <a:prstGeom prst="rect">
+            <a:avLst/>
+          </a:prstGeom>
+          <a:noFill/>
+          <a:ln/>
+        </p:spPr>
+        <p:txBody>
+          <a:bodyPr wrap="square" rtlCol="0" anchor="t"/>
+          <a:lstStyle/>
+          <a:p>
+            <a:pPr rtl="1" algn="r" indent="0" marL="0">
+              <a:buNone/>
+            </a:pPr>
+            <a:r>
+              <a:rPr lang="en-US" sz="1350" i="1" dirty="0">
+                <a:solidFill>
+                  <a:srgbClr val="6B6B80"/>
+                </a:solidFill>
+                <a:latin typeface="Arial" pitchFamily="34" charset="0"/>
+                <a:ea typeface="Arial" pitchFamily="34" charset="-122"/>
+                <a:cs typeface="Arial" pitchFamily="34" charset="-120"/>
+              </a:rPr>
+              <a:t>כל הפרומפטים המדויקים בשקפים הבאים · צריך: חשבון חינמי + דפדפן.</a:t>
+            </a:r>
+            <a:endParaRPr lang="en-US" sz="1350" dirty="0"/>
+          </a:p>
+        </p:txBody>
+      </p:sp>
+      <p:sp>
+        <p:nvSpPr>
+          <p:cNvPr id="25" name="Text 23"/>
           <p:cNvSpPr/>
           <p:nvPr/>
         </p:nvSpPr>
@@ -13033,7 +13442,7 @@
                 <a:ea typeface="Arial" pitchFamily="34" charset="-122"/>
                 <a:cs typeface="Arial" pitchFamily="34" charset="-120"/>
               </a:rPr>
-              <a:t>22 / 26</a:t>
+              <a:t>22 / 27</a:t>
             </a:r>
             <a:endParaRPr lang="en-US" sz="950" dirty="0"/>
           </a:p>
@@ -13041,7 +13450,7 @@
       </p:sp>
       <p:sp>
         <p:nvSpPr>
-          <p:cNvPr id="16" name="Text 14"/>
+          <p:cNvPr id="26" name="Text 24"/>
           <p:cNvSpPr/>
           <p:nvPr/>
         </p:nvSpPr>
@@ -13143,7 +13552,7 @@
                 <a:ea typeface="Arial" pitchFamily="34" charset="-122"/>
                 <a:cs typeface="Arial" pitchFamily="34" charset="-120"/>
               </a:rPr>
-              <a:t>משימה</a:t>
+              <a:t>ניסוי א' (8 דקות)</a:t>
             </a:r>
             <a:endParaRPr lang="en-US" sz="1250" dirty="0"/>
           </a:p>
@@ -13182,7 +13591,7 @@
                 <a:ea typeface="Arial" pitchFamily="34" charset="-122"/>
                 <a:cs typeface="Arial" pitchFamily="34" charset="-120"/>
               </a:rPr>
-              <a:t>תרגול מפגש 1</a:t>
+              <a:t>כלי מול כלי — אותו פרומפט</a:t>
             </a:r>
             <a:endParaRPr lang="en-US" sz="3300" dirty="0"/>
           </a:p>
@@ -13196,16 +13605,16 @@
         </p:nvSpPr>
         <p:spPr>
           <a:xfrm>
-            <a:off x="548640" y="1783080"/>
-            <a:ext cx="11091672" cy="1143000"/>
+            <a:off x="548640" y="1737360"/>
+            <a:ext cx="11091672" cy="1097280"/>
           </a:xfrm>
           <a:prstGeom prst="roundRect">
             <a:avLst>
-              <a:gd name="adj" fmla="val 8000"/>
+              <a:gd name="adj" fmla="val 6667"/>
             </a:avLst>
           </a:prstGeom>
           <a:solidFill>
-            <a:srgbClr val="3B3B98"/>
+            <a:srgbClr val="1B1B2B"/>
           </a:solidFill>
           <a:ln/>
           <a:effectLst>
@@ -13225,8 +13634,8 @@
         </p:nvSpPr>
         <p:spPr>
           <a:xfrm>
-            <a:off x="868680" y="1965960"/>
-            <a:ext cx="10451592" cy="777240"/>
+            <a:off x="9262872" y="1828800"/>
+            <a:ext cx="2194560" cy="320040"/>
           </a:xfrm>
           <a:prstGeom prst="rect">
             <a:avLst/>
@@ -13242,7 +13651,144 @@
               <a:buNone/>
             </a:pPr>
             <a:r>
-              <a:rPr lang="en-US" sz="1900" b="1" dirty="0">
+              <a:rPr lang="en-US" sz="1250" b="1" dirty="0">
+                <a:solidFill>
+                  <a:srgbClr val="0E9AA7"/>
+                </a:solidFill>
+                <a:latin typeface="Arial" pitchFamily="34" charset="0"/>
+                <a:ea typeface="Arial" pitchFamily="34" charset="-122"/>
+                <a:cs typeface="Arial" pitchFamily="34" charset="-120"/>
+              </a:rPr>
+              <a:t>הפרומפט (עברית):</a:t>
+            </a:r>
+            <a:endParaRPr lang="en-US" sz="1250" dirty="0"/>
+          </a:p>
+        </p:txBody>
+      </p:sp>
+      <p:sp>
+        <p:nvSpPr>
+          <p:cNvPr id="6" name="Text 4"/>
+          <p:cNvSpPr/>
+          <p:nvPr/>
+        </p:nvSpPr>
+        <p:spPr>
+          <a:xfrm>
+            <a:off x="822960" y="2194560"/>
+            <a:ext cx="10543032" cy="548640"/>
+          </a:xfrm>
+          <a:prstGeom prst="rect">
+            <a:avLst/>
+          </a:prstGeom>
+          <a:noFill/>
+          <a:ln/>
+        </p:spPr>
+        <p:txBody>
+          <a:bodyPr wrap="square" rtlCol="0" anchor="ctr"/>
+          <a:lstStyle/>
+          <a:p>
+            <a:pPr rtl="1" algn="r" indent="0" marL="0">
+              <a:buNone/>
+            </a:pPr>
+            <a:r>
+              <a:rPr lang="en-US" sz="1350" dirty="0">
+                <a:solidFill>
+                  <a:srgbClr val="E8E8F0"/>
+                </a:solidFill>
+                <a:latin typeface="Arial" pitchFamily="34" charset="0"/>
+                <a:ea typeface="Arial" pitchFamily="34" charset="-122"/>
+                <a:cs typeface="Arial" pitchFamily="34" charset="-120"/>
+              </a:rPr>
+              <a:t>“כתוב פונקציה בפייתון שמקבלת רשימת מספרים ומחזירה את הממוצע. הוסף טיפול ברשימה ריקה, והסבר בעברית מה הקוד עושה.”</a:t>
+            </a:r>
+            <a:endParaRPr lang="en-US" sz="1350" dirty="0"/>
+          </a:p>
+        </p:txBody>
+      </p:sp>
+      <p:sp>
+        <p:nvSpPr>
+          <p:cNvPr id="7" name="Text 5"/>
+          <p:cNvSpPr/>
+          <p:nvPr/>
+        </p:nvSpPr>
+        <p:spPr>
+          <a:xfrm>
+            <a:off x="548640" y="3063240"/>
+            <a:ext cx="11091672" cy="365760"/>
+          </a:xfrm>
+          <a:prstGeom prst="rect">
+            <a:avLst/>
+          </a:prstGeom>
+          <a:noFill/>
+          <a:ln/>
+        </p:spPr>
+        <p:txBody>
+          <a:bodyPr wrap="square" rtlCol="0" anchor="t"/>
+          <a:lstStyle/>
+          <a:p>
+            <a:pPr rtl="1" algn="r" indent="0" marL="0">
+              <a:buNone/>
+            </a:pPr>
+            <a:r>
+              <a:rPr lang="en-US" sz="1500" b="1" dirty="0">
+                <a:solidFill>
+                  <a:srgbClr val="1E2761"/>
+                </a:solidFill>
+                <a:latin typeface="Arial" pitchFamily="34" charset="0"/>
+                <a:ea typeface="Arial" pitchFamily="34" charset="-122"/>
+                <a:cs typeface="Arial" pitchFamily="34" charset="-120"/>
+              </a:rPr>
+              <a:t>הריצו את הפרומפט בשני הכלים שבחרתם, ואז השוו:</a:t>
+            </a:r>
+            <a:endParaRPr lang="en-US" sz="1500" dirty="0"/>
+          </a:p>
+        </p:txBody>
+      </p:sp>
+      <p:sp>
+        <p:nvSpPr>
+          <p:cNvPr id="8" name="Shape 6"/>
+          <p:cNvSpPr/>
+          <p:nvPr/>
+        </p:nvSpPr>
+        <p:spPr>
+          <a:xfrm>
+            <a:off x="11228832" y="3520440"/>
+            <a:ext cx="411480" cy="411480"/>
+          </a:xfrm>
+          <a:prstGeom prst="ellipse">
+            <a:avLst/>
+          </a:prstGeom>
+          <a:solidFill>
+            <a:srgbClr val="3B3B98"/>
+          </a:solidFill>
+          <a:ln/>
+        </p:spPr>
+      </p:sp>
+      <p:sp>
+        <p:nvSpPr>
+          <p:cNvPr id="9" name="Text 7"/>
+          <p:cNvSpPr/>
+          <p:nvPr/>
+        </p:nvSpPr>
+        <p:spPr>
+          <a:xfrm>
+            <a:off x="11228832" y="3520440"/>
+            <a:ext cx="411480" cy="411480"/>
+          </a:xfrm>
+          <a:prstGeom prst="rect">
+            <a:avLst/>
+          </a:prstGeom>
+          <a:noFill/>
+          <a:ln/>
+        </p:spPr>
+        <p:txBody>
+          <a:bodyPr wrap="square" rtlCol="0" anchor="ctr"/>
+          <a:lstStyle/>
+          <a:p>
+            <a:pPr algn="ctr" indent="0" marL="0">
+              <a:buNone/>
+            </a:pPr>
+            <a:r>
+              <a:rPr lang="en-US" sz="1600" b="1" dirty="0">
                 <a:solidFill>
                   <a:srgbClr val="FFFFFF"/>
                 </a:solidFill>
@@ -13250,22 +13796,22 @@
                 <a:ea typeface="Arial" pitchFamily="34" charset="-122"/>
                 <a:cs typeface="Arial" pitchFamily="34" charset="-120"/>
               </a:rPr>
-              <a:t>בזוגות או ביחיד: הירשמו ל-2 כלי AI חינמיים, הריצו את אותו פרומפט בשניהם, והשוו את התוצאות.</a:t>
-            </a:r>
-            <a:endParaRPr lang="en-US" sz="1900" dirty="0"/>
-          </a:p>
-        </p:txBody>
-      </p:sp>
-      <p:sp>
-        <p:nvSpPr>
-          <p:cNvPr id="6" name="Text 4"/>
-          <p:cNvSpPr/>
-          <p:nvPr/>
-        </p:nvSpPr>
-        <p:spPr>
-          <a:xfrm>
-            <a:off x="548640" y="3200400"/>
-            <a:ext cx="11091672" cy="365760"/>
+              <a:t>1</a:t>
+            </a:r>
+            <a:endParaRPr lang="en-US" sz="1600" dirty="0"/>
+          </a:p>
+        </p:txBody>
+      </p:sp>
+      <p:sp>
+        <p:nvSpPr>
+          <p:cNvPr id="10" name="Text 8"/>
+          <p:cNvSpPr/>
+          <p:nvPr/>
+        </p:nvSpPr>
+        <p:spPr>
+          <a:xfrm>
+            <a:off x="548640" y="3502152"/>
+            <a:ext cx="10515600" cy="384048"/>
           </a:xfrm>
           <a:prstGeom prst="rect">
             <a:avLst/>
@@ -13281,59 +13827,89 @@
               <a:buNone/>
             </a:pPr>
             <a:r>
-              <a:rPr lang="en-US" sz="1500" b="1" dirty="0">
-                <a:solidFill>
-                  <a:srgbClr val="1E2761"/>
-                </a:solidFill>
-                <a:latin typeface="Arial" pitchFamily="34" charset="0"/>
-                <a:ea typeface="Arial" pitchFamily="34" charset="-122"/>
-                <a:cs typeface="Arial" pitchFamily="34" charset="-120"/>
-              </a:rPr>
-              <a:t>כלים אפשריים (בחרו 2):</a:t>
-            </a:r>
-            <a:endParaRPr lang="en-US" sz="1500" dirty="0"/>
-          </a:p>
-        </p:txBody>
-      </p:sp>
-      <p:sp>
-        <p:nvSpPr>
-          <p:cNvPr id="7" name="Shape 5"/>
-          <p:cNvSpPr/>
-          <p:nvPr/>
-        </p:nvSpPr>
-        <p:spPr>
-          <a:xfrm>
-            <a:off x="8125968" y="3657600"/>
-            <a:ext cx="3514344" cy="1005840"/>
-          </a:xfrm>
-          <a:prstGeom prst="roundRect">
-            <a:avLst>
-              <a:gd name="adj" fmla="val 8182"/>
-            </a:avLst>
+              <a:rPr lang="en-US" sz="1700" b="1" dirty="0">
+                <a:solidFill>
+                  <a:srgbClr val="222232"/>
+                </a:solidFill>
+                <a:latin typeface="Arial" pitchFamily="34" charset="0"/>
+                <a:ea typeface="Arial" pitchFamily="34" charset="-122"/>
+                <a:cs typeface="Arial" pitchFamily="34" charset="-120"/>
+              </a:rPr>
+              <a:t>מי הסביר טוב יותר?</a:t>
+            </a:r>
+            <a:endParaRPr lang="en-US" sz="1700" dirty="0"/>
+          </a:p>
+        </p:txBody>
+      </p:sp>
+      <p:sp>
+        <p:nvSpPr>
+          <p:cNvPr id="11" name="Shape 9"/>
+          <p:cNvSpPr/>
+          <p:nvPr/>
+        </p:nvSpPr>
+        <p:spPr>
+          <a:xfrm>
+            <a:off x="11228832" y="4160520"/>
+            <a:ext cx="411480" cy="411480"/>
+          </a:xfrm>
+          <a:prstGeom prst="ellipse">
+            <a:avLst/>
           </a:prstGeom>
           <a:solidFill>
-            <a:srgbClr val="E7F5F6"/>
+            <a:srgbClr val="3B3B98"/>
           </a:solidFill>
           <a:ln/>
-          <a:effectLst>
-            <a:outerShdw sx="100000" sy="100000" kx="0" ky="0" algn="bl" rotWithShape="0" blurRad="76200" dist="25400" dir="5400000">
-              <a:srgbClr val="999999">
-                <a:alpha val="28000"/>
-              </a:srgbClr>
-            </a:outerShdw>
-          </a:effectLst>
-        </p:spPr>
-      </p:sp>
-      <p:sp>
-        <p:nvSpPr>
-          <p:cNvPr id="8" name="Text 6"/>
-          <p:cNvSpPr/>
-          <p:nvPr/>
-        </p:nvSpPr>
-        <p:spPr>
-          <a:xfrm>
-            <a:off x="8308848" y="3840480"/>
-            <a:ext cx="3148584" cy="411480"/>
+        </p:spPr>
+      </p:sp>
+      <p:sp>
+        <p:nvSpPr>
+          <p:cNvPr id="12" name="Text 10"/>
+          <p:cNvSpPr/>
+          <p:nvPr/>
+        </p:nvSpPr>
+        <p:spPr>
+          <a:xfrm>
+            <a:off x="11228832" y="4160520"/>
+            <a:ext cx="411480" cy="411480"/>
+          </a:xfrm>
+          <a:prstGeom prst="rect">
+            <a:avLst/>
+          </a:prstGeom>
+          <a:noFill/>
+          <a:ln/>
+        </p:spPr>
+        <p:txBody>
+          <a:bodyPr wrap="square" rtlCol="0" anchor="ctr"/>
+          <a:lstStyle/>
+          <a:p>
+            <a:pPr algn="ctr" indent="0" marL="0">
+              <a:buNone/>
+            </a:pPr>
+            <a:r>
+              <a:rPr lang="en-US" sz="1600" b="1" dirty="0">
+                <a:solidFill>
+                  <a:srgbClr val="FFFFFF"/>
+                </a:solidFill>
+                <a:latin typeface="Arial" pitchFamily="34" charset="0"/>
+                <a:ea typeface="Arial" pitchFamily="34" charset="-122"/>
+                <a:cs typeface="Arial" pitchFamily="34" charset="-120"/>
+              </a:rPr>
+              <a:t>2</a:t>
+            </a:r>
+            <a:endParaRPr lang="en-US" sz="1600" dirty="0"/>
+          </a:p>
+        </p:txBody>
+      </p:sp>
+      <p:sp>
+        <p:nvSpPr>
+          <p:cNvPr id="13" name="Text 11"/>
+          <p:cNvSpPr/>
+          <p:nvPr/>
+        </p:nvSpPr>
+        <p:spPr>
+          <a:xfrm>
+            <a:off x="548640" y="4142232"/>
+            <a:ext cx="10515600" cy="384048"/>
           </a:xfrm>
           <a:prstGeom prst="rect">
             <a:avLst/>
@@ -13345,7 +13921,7 @@
           <a:bodyPr wrap="square" rtlCol="0" anchor="t"/>
           <a:lstStyle/>
           <a:p>
-            <a:pPr rtl="1" algn="ctr" indent="0" marL="0">
+            <a:pPr rtl="1" algn="r" indent="0" marL="0">
               <a:buNone/>
             </a:pPr>
             <a:r>
@@ -13357,7 +13933,7 @@
                 <a:ea typeface="Arial" pitchFamily="34" charset="-122"/>
                 <a:cs typeface="Arial" pitchFamily="34" charset="-120"/>
               </a:rPr>
-              <a:t>Claude.ai</a:t>
+              <a:t>מי טיפל במקרה הקצה (רשימה ריקה)?</a:t>
             </a:r>
             <a:endParaRPr lang="en-US" sz="1700" dirty="0"/>
           </a:p>
@@ -13365,14 +13941,73 @@
       </p:sp>
       <p:sp>
         <p:nvSpPr>
-          <p:cNvPr id="9" name="Text 7"/>
-          <p:cNvSpPr/>
-          <p:nvPr/>
-        </p:nvSpPr>
-        <p:spPr>
-          <a:xfrm>
-            <a:off x="8308848" y="4251960"/>
-            <a:ext cx="3148584" cy="320040"/>
+          <p:cNvPr id="14" name="Shape 12"/>
+          <p:cNvSpPr/>
+          <p:nvPr/>
+        </p:nvSpPr>
+        <p:spPr>
+          <a:xfrm>
+            <a:off x="11228832" y="4800600"/>
+            <a:ext cx="411480" cy="411480"/>
+          </a:xfrm>
+          <a:prstGeom prst="ellipse">
+            <a:avLst/>
+          </a:prstGeom>
+          <a:solidFill>
+            <a:srgbClr val="3B3B98"/>
+          </a:solidFill>
+          <a:ln/>
+        </p:spPr>
+      </p:sp>
+      <p:sp>
+        <p:nvSpPr>
+          <p:cNvPr id="15" name="Text 13"/>
+          <p:cNvSpPr/>
+          <p:nvPr/>
+        </p:nvSpPr>
+        <p:spPr>
+          <a:xfrm>
+            <a:off x="11228832" y="4800600"/>
+            <a:ext cx="411480" cy="411480"/>
+          </a:xfrm>
+          <a:prstGeom prst="rect">
+            <a:avLst/>
+          </a:prstGeom>
+          <a:noFill/>
+          <a:ln/>
+        </p:spPr>
+        <p:txBody>
+          <a:bodyPr wrap="square" rtlCol="0" anchor="ctr"/>
+          <a:lstStyle/>
+          <a:p>
+            <a:pPr algn="ctr" indent="0" marL="0">
+              <a:buNone/>
+            </a:pPr>
+            <a:r>
+              <a:rPr lang="en-US" sz="1600" b="1" dirty="0">
+                <a:solidFill>
+                  <a:srgbClr val="FFFFFF"/>
+                </a:solidFill>
+                <a:latin typeface="Arial" pitchFamily="34" charset="0"/>
+                <a:ea typeface="Arial" pitchFamily="34" charset="-122"/>
+                <a:cs typeface="Arial" pitchFamily="34" charset="-120"/>
+              </a:rPr>
+              <a:t>3</a:t>
+            </a:r>
+            <a:endParaRPr lang="en-US" sz="1600" dirty="0"/>
+          </a:p>
+        </p:txBody>
+      </p:sp>
+      <p:sp>
+        <p:nvSpPr>
+          <p:cNvPr id="16" name="Text 14"/>
+          <p:cNvSpPr/>
+          <p:nvPr/>
+        </p:nvSpPr>
+        <p:spPr>
+          <a:xfrm>
+            <a:off x="548640" y="4782312"/>
+            <a:ext cx="10515600" cy="384048"/>
           </a:xfrm>
           <a:prstGeom prst="rect">
             <a:avLst/>
@@ -13384,75 +14019,7 @@
           <a:bodyPr wrap="square" rtlCol="0" anchor="t"/>
           <a:lstStyle/>
           <a:p>
-            <a:pPr rtl="1" algn="ctr" indent="0" marL="0">
-              <a:buNone/>
-            </a:pPr>
-            <a:r>
-              <a:rPr lang="en-US" sz="1300" dirty="0">
-                <a:solidFill>
-                  <a:srgbClr val="0E9AA7"/>
-                </a:solidFill>
-                <a:latin typeface="Arial" pitchFamily="34" charset="0"/>
-                <a:ea typeface="Arial" pitchFamily="34" charset="-122"/>
-                <a:cs typeface="Arial" pitchFamily="34" charset="-120"/>
-              </a:rPr>
-              <a:t>צ’אט</a:t>
-            </a:r>
-            <a:endParaRPr lang="en-US" sz="1300" dirty="0"/>
-          </a:p>
-        </p:txBody>
-      </p:sp>
-      <p:sp>
-        <p:nvSpPr>
-          <p:cNvPr id="10" name="Shape 8"/>
-          <p:cNvSpPr/>
-          <p:nvPr/>
-        </p:nvSpPr>
-        <p:spPr>
-          <a:xfrm>
-            <a:off x="4337304" y="3657600"/>
-            <a:ext cx="3514344" cy="1005840"/>
-          </a:xfrm>
-          <a:prstGeom prst="roundRect">
-            <a:avLst>
-              <a:gd name="adj" fmla="val 8182"/>
-            </a:avLst>
-          </a:prstGeom>
-          <a:solidFill>
-            <a:srgbClr val="E7F5F6"/>
-          </a:solidFill>
-          <a:ln/>
-          <a:effectLst>
-            <a:outerShdw sx="100000" sy="100000" kx="0" ky="0" algn="bl" rotWithShape="0" blurRad="76200" dist="25400" dir="5400000">
-              <a:srgbClr val="999999">
-                <a:alpha val="28000"/>
-              </a:srgbClr>
-            </a:outerShdw>
-          </a:effectLst>
-        </p:spPr>
-      </p:sp>
-      <p:sp>
-        <p:nvSpPr>
-          <p:cNvPr id="11" name="Text 9"/>
-          <p:cNvSpPr/>
-          <p:nvPr/>
-        </p:nvSpPr>
-        <p:spPr>
-          <a:xfrm>
-            <a:off x="4520184" y="3840480"/>
-            <a:ext cx="3148584" cy="411480"/>
-          </a:xfrm>
-          <a:prstGeom prst="rect">
-            <a:avLst/>
-          </a:prstGeom>
-          <a:noFill/>
-          <a:ln/>
-        </p:spPr>
-        <p:txBody>
-          <a:bodyPr wrap="square" rtlCol="0" anchor="t"/>
-          <a:lstStyle/>
-          <a:p>
-            <a:pPr rtl="1" algn="ctr" indent="0" marL="0">
+            <a:pPr rtl="1" algn="r" indent="0" marL="0">
               <a:buNone/>
             </a:pPr>
             <a:r>
@@ -13464,194 +14031,9 @@
                 <a:ea typeface="Arial" pitchFamily="34" charset="-122"/>
                 <a:cs typeface="Arial" pitchFamily="34" charset="-120"/>
               </a:rPr>
-              <a:t>ChatGPT</a:t>
+              <a:t>אילו הבדלים יש בקוד עצמו (שמות, מבנה, הערות)?</a:t>
             </a:r>
             <a:endParaRPr lang="en-US" sz="1700" dirty="0"/>
-          </a:p>
-        </p:txBody>
-      </p:sp>
-      <p:sp>
-        <p:nvSpPr>
-          <p:cNvPr id="12" name="Text 10"/>
-          <p:cNvSpPr/>
-          <p:nvPr/>
-        </p:nvSpPr>
-        <p:spPr>
-          <a:xfrm>
-            <a:off x="4520184" y="4251960"/>
-            <a:ext cx="3148584" cy="320040"/>
-          </a:xfrm>
-          <a:prstGeom prst="rect">
-            <a:avLst/>
-          </a:prstGeom>
-          <a:noFill/>
-          <a:ln/>
-        </p:spPr>
-        <p:txBody>
-          <a:bodyPr wrap="square" rtlCol="0" anchor="t"/>
-          <a:lstStyle/>
-          <a:p>
-            <a:pPr rtl="1" algn="ctr" indent="0" marL="0">
-              <a:buNone/>
-            </a:pPr>
-            <a:r>
-              <a:rPr lang="en-US" sz="1300" dirty="0">
-                <a:solidFill>
-                  <a:srgbClr val="0E9AA7"/>
-                </a:solidFill>
-                <a:latin typeface="Arial" pitchFamily="34" charset="0"/>
-                <a:ea typeface="Arial" pitchFamily="34" charset="-122"/>
-                <a:cs typeface="Arial" pitchFamily="34" charset="-120"/>
-              </a:rPr>
-              <a:t>צ’אט</a:t>
-            </a:r>
-            <a:endParaRPr lang="en-US" sz="1300" dirty="0"/>
-          </a:p>
-        </p:txBody>
-      </p:sp>
-      <p:sp>
-        <p:nvSpPr>
-          <p:cNvPr id="13" name="Shape 11"/>
-          <p:cNvSpPr/>
-          <p:nvPr/>
-        </p:nvSpPr>
-        <p:spPr>
-          <a:xfrm>
-            <a:off x="548640" y="3657600"/>
-            <a:ext cx="3514344" cy="1005840"/>
-          </a:xfrm>
-          <a:prstGeom prst="roundRect">
-            <a:avLst>
-              <a:gd name="adj" fmla="val 8182"/>
-            </a:avLst>
-          </a:prstGeom>
-          <a:solidFill>
-            <a:srgbClr val="E7F5F6"/>
-          </a:solidFill>
-          <a:ln/>
-          <a:effectLst>
-            <a:outerShdw sx="100000" sy="100000" kx="0" ky="0" algn="bl" rotWithShape="0" blurRad="76200" dist="25400" dir="5400000">
-              <a:srgbClr val="999999">
-                <a:alpha val="28000"/>
-              </a:srgbClr>
-            </a:outerShdw>
-          </a:effectLst>
-        </p:spPr>
-      </p:sp>
-      <p:sp>
-        <p:nvSpPr>
-          <p:cNvPr id="14" name="Text 12"/>
-          <p:cNvSpPr/>
-          <p:nvPr/>
-        </p:nvSpPr>
-        <p:spPr>
-          <a:xfrm>
-            <a:off x="731520" y="3840480"/>
-            <a:ext cx="3148584" cy="411480"/>
-          </a:xfrm>
-          <a:prstGeom prst="rect">
-            <a:avLst/>
-          </a:prstGeom>
-          <a:noFill/>
-          <a:ln/>
-        </p:spPr>
-        <p:txBody>
-          <a:bodyPr wrap="square" rtlCol="0" anchor="t"/>
-          <a:lstStyle/>
-          <a:p>
-            <a:pPr rtl="1" algn="ctr" indent="0" marL="0">
-              <a:buNone/>
-            </a:pPr>
-            <a:r>
-              <a:rPr lang="en-US" sz="1700" b="1" dirty="0">
-                <a:solidFill>
-                  <a:srgbClr val="222232"/>
-                </a:solidFill>
-                <a:latin typeface="Arial" pitchFamily="34" charset="0"/>
-                <a:ea typeface="Arial" pitchFamily="34" charset="-122"/>
-                <a:cs typeface="Arial" pitchFamily="34" charset="-120"/>
-              </a:rPr>
-              <a:t>Copilot Free</a:t>
-            </a:r>
-            <a:endParaRPr lang="en-US" sz="1700" dirty="0"/>
-          </a:p>
-        </p:txBody>
-      </p:sp>
-      <p:sp>
-        <p:nvSpPr>
-          <p:cNvPr id="15" name="Text 13"/>
-          <p:cNvSpPr/>
-          <p:nvPr/>
-        </p:nvSpPr>
-        <p:spPr>
-          <a:xfrm>
-            <a:off x="731520" y="4251960"/>
-            <a:ext cx="3148584" cy="320040"/>
-          </a:xfrm>
-          <a:prstGeom prst="rect">
-            <a:avLst/>
-          </a:prstGeom>
-          <a:noFill/>
-          <a:ln/>
-        </p:spPr>
-        <p:txBody>
-          <a:bodyPr wrap="square" rtlCol="0" anchor="t"/>
-          <a:lstStyle/>
-          <a:p>
-            <a:pPr rtl="1" algn="ctr" indent="0" marL="0">
-              <a:buNone/>
-            </a:pPr>
-            <a:r>
-              <a:rPr lang="en-US" sz="1300" dirty="0">
-                <a:solidFill>
-                  <a:srgbClr val="0E9AA7"/>
-                </a:solidFill>
-                <a:latin typeface="Arial" pitchFamily="34" charset="0"/>
-                <a:ea typeface="Arial" pitchFamily="34" charset="-122"/>
-                <a:cs typeface="Arial" pitchFamily="34" charset="-120"/>
-              </a:rPr>
-              <a:t>IDE</a:t>
-            </a:r>
-            <a:endParaRPr lang="en-US" sz="1300" dirty="0"/>
-          </a:p>
-        </p:txBody>
-      </p:sp>
-      <p:sp>
-        <p:nvSpPr>
-          <p:cNvPr id="16" name="Text 14"/>
-          <p:cNvSpPr/>
-          <p:nvPr/>
-        </p:nvSpPr>
-        <p:spPr>
-          <a:xfrm>
-            <a:off x="548640" y="4892040"/>
-            <a:ext cx="11091672" cy="365760"/>
-          </a:xfrm>
-          <a:prstGeom prst="rect">
-            <a:avLst/>
-          </a:prstGeom>
-          <a:noFill/>
-          <a:ln/>
-        </p:spPr>
-        <p:txBody>
-          <a:bodyPr wrap="square" rtlCol="0" anchor="t"/>
-          <a:lstStyle/>
-          <a:p>
-            <a:pPr rtl="1" algn="r" indent="0" marL="0">
-              <a:buNone/>
-            </a:pPr>
-            <a:r>
-              <a:rPr lang="en-US" sz="1350" i="1" dirty="0">
-                <a:solidFill>
-                  <a:srgbClr val="6B6B80"/>
-                </a:solidFill>
-                <a:latin typeface="Arial" pitchFamily="34" charset="0"/>
-                <a:ea typeface="Arial" pitchFamily="34" charset="-122"/>
-                <a:cs typeface="Arial" pitchFamily="34" charset="-120"/>
-              </a:rPr>
-              <a:t>אין חובה דווקא באלה — כל כלי חינמי מהרשימה מתאים.</a:t>
-            </a:r>
-            <a:endParaRPr lang="en-US" sz="1350" dirty="0"/>
           </a:p>
         </p:txBody>
       </p:sp>
@@ -13688,7 +14070,7 @@
                 <a:ea typeface="Arial" pitchFamily="34" charset="-122"/>
                 <a:cs typeface="Arial" pitchFamily="34" charset="-120"/>
               </a:rPr>
-              <a:t>23 / 26</a:t>
+              <a:t>23 / 27</a:t>
             </a:r>
             <a:endParaRPr lang="en-US" sz="950" dirty="0"/>
           </a:p>
@@ -13798,7 +14180,7 @@
                 <a:ea typeface="Arial" pitchFamily="34" charset="-122"/>
                 <a:cs typeface="Arial" pitchFamily="34" charset="-120"/>
               </a:rPr>
-              <a:t>הנחיות</a:t>
+              <a:t>ניסוי ב' (14 דקות) — הלב של התרגול</a:t>
             </a:r>
             <a:endParaRPr lang="en-US" sz="1250" dirty="0"/>
           </a:p>
@@ -13837,7 +14219,7 @@
                 <a:ea typeface="Arial" pitchFamily="34" charset="-122"/>
                 <a:cs typeface="Arial" pitchFamily="34" charset="-120"/>
               </a:rPr>
-              <a:t>תרגול — שלב אחר שלב</a:t>
+              <a:t>עברית מול אנגלית</a:t>
             </a:r>
             <a:endParaRPr lang="en-US" sz="3300" dirty="0"/>
           </a:p>
@@ -13845,73 +14227,14 @@
       </p:sp>
       <p:sp>
         <p:nvSpPr>
-          <p:cNvPr id="4" name="Shape 2"/>
-          <p:cNvSpPr/>
-          <p:nvPr/>
-        </p:nvSpPr>
-        <p:spPr>
-          <a:xfrm>
-            <a:off x="11237976" y="1691640"/>
-            <a:ext cx="402336" cy="402336"/>
-          </a:xfrm>
-          <a:prstGeom prst="ellipse">
-            <a:avLst/>
-          </a:prstGeom>
-          <a:solidFill>
-            <a:srgbClr val="3B3B98"/>
-          </a:solidFill>
-          <a:ln/>
-        </p:spPr>
-      </p:sp>
-      <p:sp>
-        <p:nvSpPr>
-          <p:cNvPr id="5" name="Text 3"/>
-          <p:cNvSpPr/>
-          <p:nvPr/>
-        </p:nvSpPr>
-        <p:spPr>
-          <a:xfrm>
-            <a:off x="11237976" y="1691640"/>
-            <a:ext cx="402336" cy="402336"/>
-          </a:xfrm>
-          <a:prstGeom prst="rect">
-            <a:avLst/>
-          </a:prstGeom>
-          <a:noFill/>
-          <a:ln/>
-        </p:spPr>
-        <p:txBody>
-          <a:bodyPr wrap="square" rtlCol="0" anchor="ctr"/>
-          <a:lstStyle/>
-          <a:p>
-            <a:pPr algn="ctr" indent="0" marL="0">
-              <a:buNone/>
-            </a:pPr>
-            <a:r>
-              <a:rPr lang="en-US" sz="1600" b="1" dirty="0">
-                <a:solidFill>
-                  <a:srgbClr val="FFFFFF"/>
-                </a:solidFill>
-                <a:latin typeface="Arial" pitchFamily="34" charset="0"/>
-                <a:ea typeface="Arial" pitchFamily="34" charset="-122"/>
-                <a:cs typeface="Arial" pitchFamily="34" charset="-120"/>
-              </a:rPr>
-              <a:t>1</a:t>
-            </a:r>
-            <a:endParaRPr lang="en-US" sz="1600" dirty="0"/>
-          </a:p>
-        </p:txBody>
-      </p:sp>
-      <p:sp>
-        <p:nvSpPr>
-          <p:cNvPr id="6" name="Text 4"/>
-          <p:cNvSpPr/>
-          <p:nvPr/>
-        </p:nvSpPr>
-        <p:spPr>
-          <a:xfrm>
-            <a:off x="548640" y="1673352"/>
-            <a:ext cx="10524744" cy="384048"/>
+          <p:cNvPr id="4" name="Text 2"/>
+          <p:cNvSpPr/>
+          <p:nvPr/>
+        </p:nvSpPr>
+        <p:spPr>
+          <a:xfrm>
+            <a:off x="548640" y="1627632"/>
+            <a:ext cx="11091672" cy="365760"/>
           </a:xfrm>
           <a:prstGeom prst="rect">
             <a:avLst/>
@@ -13927,426 +14250,34 @@
               <a:buNone/>
             </a:pPr>
             <a:r>
-              <a:rPr lang="en-US" sz="1700" b="1" dirty="0">
-                <a:solidFill>
-                  <a:srgbClr val="222232"/>
-                </a:solidFill>
-                <a:latin typeface="Arial" pitchFamily="34" charset="0"/>
-                <a:ea typeface="Arial" pitchFamily="34" charset="-122"/>
-                <a:cs typeface="Arial" pitchFamily="34" charset="-120"/>
-              </a:rPr>
-              <a:t>בחרו 2 כלים חינמיים מהרשימה (למשל Claude.ai + ChatGPT).</a:t>
-            </a:r>
-            <a:endParaRPr lang="en-US" sz="1700" dirty="0"/>
-          </a:p>
-        </p:txBody>
-      </p:sp>
-      <p:sp>
-        <p:nvSpPr>
-          <p:cNvPr id="7" name="Shape 5"/>
-          <p:cNvSpPr/>
-          <p:nvPr/>
-        </p:nvSpPr>
-        <p:spPr>
-          <a:xfrm>
-            <a:off x="11237976" y="2295144"/>
-            <a:ext cx="402336" cy="402336"/>
-          </a:xfrm>
-          <a:prstGeom prst="ellipse">
-            <a:avLst/>
-          </a:prstGeom>
-          <a:solidFill>
-            <a:srgbClr val="3B3B98"/>
-          </a:solidFill>
-          <a:ln/>
-        </p:spPr>
-      </p:sp>
-      <p:sp>
-        <p:nvSpPr>
-          <p:cNvPr id="8" name="Text 6"/>
-          <p:cNvSpPr/>
-          <p:nvPr/>
-        </p:nvSpPr>
-        <p:spPr>
-          <a:xfrm>
-            <a:off x="11237976" y="2295144"/>
-            <a:ext cx="402336" cy="402336"/>
-          </a:xfrm>
-          <a:prstGeom prst="rect">
-            <a:avLst/>
-          </a:prstGeom>
-          <a:noFill/>
-          <a:ln/>
-        </p:spPr>
-        <p:txBody>
-          <a:bodyPr wrap="square" rtlCol="0" anchor="ctr"/>
-          <a:lstStyle/>
-          <a:p>
-            <a:pPr algn="ctr" indent="0" marL="0">
-              <a:buNone/>
-            </a:pPr>
-            <a:r>
-              <a:rPr lang="en-US" sz="1600" b="1" dirty="0">
-                <a:solidFill>
-                  <a:srgbClr val="FFFFFF"/>
-                </a:solidFill>
-                <a:latin typeface="Arial" pitchFamily="34" charset="0"/>
-                <a:ea typeface="Arial" pitchFamily="34" charset="-122"/>
-                <a:cs typeface="Arial" pitchFamily="34" charset="-120"/>
-              </a:rPr>
-              <a:t>2</a:t>
-            </a:r>
-            <a:endParaRPr lang="en-US" sz="1600" dirty="0"/>
-          </a:p>
-        </p:txBody>
-      </p:sp>
-      <p:sp>
-        <p:nvSpPr>
-          <p:cNvPr id="9" name="Text 7"/>
-          <p:cNvSpPr/>
-          <p:nvPr/>
-        </p:nvSpPr>
-        <p:spPr>
-          <a:xfrm>
-            <a:off x="548640" y="2276856"/>
-            <a:ext cx="10524744" cy="384048"/>
-          </a:xfrm>
-          <a:prstGeom prst="rect">
-            <a:avLst/>
-          </a:prstGeom>
-          <a:noFill/>
-          <a:ln/>
-        </p:spPr>
-        <p:txBody>
-          <a:bodyPr wrap="square" rtlCol="0" anchor="t"/>
-          <a:lstStyle/>
-          <a:p>
-            <a:pPr rtl="1" algn="r" indent="0" marL="0">
-              <a:buNone/>
-            </a:pPr>
-            <a:r>
-              <a:rPr lang="en-US" sz="1700" b="1" dirty="0">
-                <a:solidFill>
-                  <a:srgbClr val="222232"/>
-                </a:solidFill>
-                <a:latin typeface="Arial" pitchFamily="34" charset="0"/>
-                <a:ea typeface="Arial" pitchFamily="34" charset="-122"/>
-                <a:cs typeface="Arial" pitchFamily="34" charset="-120"/>
-              </a:rPr>
-              <a:t>הירשמו לכל אחד — חשבון חינמי עם דוא“ל.</a:t>
-            </a:r>
-            <a:endParaRPr lang="en-US" sz="1700" dirty="0"/>
-          </a:p>
-        </p:txBody>
-      </p:sp>
-      <p:sp>
-        <p:nvSpPr>
-          <p:cNvPr id="10" name="Shape 8"/>
-          <p:cNvSpPr/>
-          <p:nvPr/>
-        </p:nvSpPr>
-        <p:spPr>
-          <a:xfrm>
-            <a:off x="11237976" y="2898648"/>
-            <a:ext cx="402336" cy="402336"/>
-          </a:xfrm>
-          <a:prstGeom prst="ellipse">
-            <a:avLst/>
-          </a:prstGeom>
-          <a:solidFill>
-            <a:srgbClr val="3B3B98"/>
-          </a:solidFill>
-          <a:ln/>
-        </p:spPr>
-      </p:sp>
-      <p:sp>
-        <p:nvSpPr>
-          <p:cNvPr id="11" name="Text 9"/>
-          <p:cNvSpPr/>
-          <p:nvPr/>
-        </p:nvSpPr>
-        <p:spPr>
-          <a:xfrm>
-            <a:off x="11237976" y="2898648"/>
-            <a:ext cx="402336" cy="402336"/>
-          </a:xfrm>
-          <a:prstGeom prst="rect">
-            <a:avLst/>
-          </a:prstGeom>
-          <a:noFill/>
-          <a:ln/>
-        </p:spPr>
-        <p:txBody>
-          <a:bodyPr wrap="square" rtlCol="0" anchor="ctr"/>
-          <a:lstStyle/>
-          <a:p>
-            <a:pPr algn="ctr" indent="0" marL="0">
-              <a:buNone/>
-            </a:pPr>
-            <a:r>
-              <a:rPr lang="en-US" sz="1600" b="1" dirty="0">
-                <a:solidFill>
-                  <a:srgbClr val="FFFFFF"/>
-                </a:solidFill>
-                <a:latin typeface="Arial" pitchFamily="34" charset="0"/>
-                <a:ea typeface="Arial" pitchFamily="34" charset="-122"/>
-                <a:cs typeface="Arial" pitchFamily="34" charset="-120"/>
-              </a:rPr>
-              <a:t>3</a:t>
-            </a:r>
-            <a:endParaRPr lang="en-US" sz="1600" dirty="0"/>
-          </a:p>
-        </p:txBody>
-      </p:sp>
-      <p:sp>
-        <p:nvSpPr>
-          <p:cNvPr id="12" name="Text 10"/>
-          <p:cNvSpPr/>
-          <p:nvPr/>
-        </p:nvSpPr>
-        <p:spPr>
-          <a:xfrm>
-            <a:off x="548640" y="2880360"/>
-            <a:ext cx="10524744" cy="384048"/>
-          </a:xfrm>
-          <a:prstGeom prst="rect">
-            <a:avLst/>
-          </a:prstGeom>
-          <a:noFill/>
-          <a:ln/>
-        </p:spPr>
-        <p:txBody>
-          <a:bodyPr wrap="square" rtlCol="0" anchor="t"/>
-          <a:lstStyle/>
-          <a:p>
-            <a:pPr rtl="1" algn="r" indent="0" marL="0">
-              <a:buNone/>
-            </a:pPr>
-            <a:r>
-              <a:rPr lang="en-US" sz="1700" b="1" dirty="0">
-                <a:solidFill>
-                  <a:srgbClr val="222232"/>
-                </a:solidFill>
-                <a:latin typeface="Arial" pitchFamily="34" charset="0"/>
-                <a:ea typeface="Arial" pitchFamily="34" charset="-122"/>
-                <a:cs typeface="Arial" pitchFamily="34" charset="-120"/>
-              </a:rPr>
-              <a:t>הריצו בשני הכלים את הפרומפט שבתיבה למטה.</a:t>
-            </a:r>
-            <a:endParaRPr lang="en-US" sz="1700" dirty="0"/>
-          </a:p>
-        </p:txBody>
-      </p:sp>
-      <p:sp>
-        <p:nvSpPr>
-          <p:cNvPr id="13" name="Shape 11"/>
-          <p:cNvSpPr/>
-          <p:nvPr/>
-        </p:nvSpPr>
-        <p:spPr>
-          <a:xfrm>
-            <a:off x="11237976" y="3502152"/>
-            <a:ext cx="402336" cy="402336"/>
-          </a:xfrm>
-          <a:prstGeom prst="ellipse">
-            <a:avLst/>
-          </a:prstGeom>
-          <a:solidFill>
-            <a:srgbClr val="3B3B98"/>
-          </a:solidFill>
-          <a:ln/>
-        </p:spPr>
-      </p:sp>
-      <p:sp>
-        <p:nvSpPr>
-          <p:cNvPr id="14" name="Text 12"/>
-          <p:cNvSpPr/>
-          <p:nvPr/>
-        </p:nvSpPr>
-        <p:spPr>
-          <a:xfrm>
-            <a:off x="11237976" y="3502152"/>
-            <a:ext cx="402336" cy="402336"/>
-          </a:xfrm>
-          <a:prstGeom prst="rect">
-            <a:avLst/>
-          </a:prstGeom>
-          <a:noFill/>
-          <a:ln/>
-        </p:spPr>
-        <p:txBody>
-          <a:bodyPr wrap="square" rtlCol="0" anchor="ctr"/>
-          <a:lstStyle/>
-          <a:p>
-            <a:pPr algn="ctr" indent="0" marL="0">
-              <a:buNone/>
-            </a:pPr>
-            <a:r>
-              <a:rPr lang="en-US" sz="1600" b="1" dirty="0">
-                <a:solidFill>
-                  <a:srgbClr val="FFFFFF"/>
-                </a:solidFill>
-                <a:latin typeface="Arial" pitchFamily="34" charset="0"/>
-                <a:ea typeface="Arial" pitchFamily="34" charset="-122"/>
-                <a:cs typeface="Arial" pitchFamily="34" charset="-120"/>
-              </a:rPr>
-              <a:t>4</a:t>
-            </a:r>
-            <a:endParaRPr lang="en-US" sz="1600" dirty="0"/>
-          </a:p>
-        </p:txBody>
-      </p:sp>
-      <p:sp>
-        <p:nvSpPr>
-          <p:cNvPr id="15" name="Text 13"/>
-          <p:cNvSpPr/>
-          <p:nvPr/>
-        </p:nvSpPr>
-        <p:spPr>
-          <a:xfrm>
-            <a:off x="548640" y="3483864"/>
-            <a:ext cx="10524744" cy="384048"/>
-          </a:xfrm>
-          <a:prstGeom prst="rect">
-            <a:avLst/>
-          </a:prstGeom>
-          <a:noFill/>
-          <a:ln/>
-        </p:spPr>
-        <p:txBody>
-          <a:bodyPr wrap="square" rtlCol="0" anchor="t"/>
-          <a:lstStyle/>
-          <a:p>
-            <a:pPr rtl="1" algn="r" indent="0" marL="0">
-              <a:buNone/>
-            </a:pPr>
-            <a:r>
-              <a:rPr lang="en-US" sz="1700" b="1" dirty="0">
-                <a:solidFill>
-                  <a:srgbClr val="222232"/>
-                </a:solidFill>
-                <a:latin typeface="Arial" pitchFamily="34" charset="0"/>
-                <a:ea typeface="Arial" pitchFamily="34" charset="-122"/>
-                <a:cs typeface="Arial" pitchFamily="34" charset="-120"/>
-              </a:rPr>
-              <a:t>קראו את שתי התשובות, והריצו את הקוד (למשל ב-Google Colab).</a:t>
-            </a:r>
-            <a:endParaRPr lang="en-US" sz="1700" dirty="0"/>
-          </a:p>
-        </p:txBody>
-      </p:sp>
-      <p:sp>
-        <p:nvSpPr>
-          <p:cNvPr id="16" name="Shape 14"/>
-          <p:cNvSpPr/>
-          <p:nvPr/>
-        </p:nvSpPr>
-        <p:spPr>
-          <a:xfrm>
-            <a:off x="11237976" y="4105656"/>
-            <a:ext cx="402336" cy="402336"/>
-          </a:xfrm>
-          <a:prstGeom prst="ellipse">
-            <a:avLst/>
-          </a:prstGeom>
-          <a:solidFill>
-            <a:srgbClr val="3B3B98"/>
-          </a:solidFill>
-          <a:ln/>
-        </p:spPr>
-      </p:sp>
-      <p:sp>
-        <p:nvSpPr>
-          <p:cNvPr id="17" name="Text 15"/>
-          <p:cNvSpPr/>
-          <p:nvPr/>
-        </p:nvSpPr>
-        <p:spPr>
-          <a:xfrm>
-            <a:off x="11237976" y="4105656"/>
-            <a:ext cx="402336" cy="402336"/>
-          </a:xfrm>
-          <a:prstGeom prst="rect">
-            <a:avLst/>
-          </a:prstGeom>
-          <a:noFill/>
-          <a:ln/>
-        </p:spPr>
-        <p:txBody>
-          <a:bodyPr wrap="square" rtlCol="0" anchor="ctr"/>
-          <a:lstStyle/>
-          <a:p>
-            <a:pPr algn="ctr" indent="0" marL="0">
-              <a:buNone/>
-            </a:pPr>
-            <a:r>
-              <a:rPr lang="en-US" sz="1600" b="1" dirty="0">
-                <a:solidFill>
-                  <a:srgbClr val="FFFFFF"/>
-                </a:solidFill>
-                <a:latin typeface="Arial" pitchFamily="34" charset="0"/>
-                <a:ea typeface="Arial" pitchFamily="34" charset="-122"/>
-                <a:cs typeface="Arial" pitchFamily="34" charset="-120"/>
-              </a:rPr>
-              <a:t>5</a:t>
-            </a:r>
-            <a:endParaRPr lang="en-US" sz="1600" dirty="0"/>
-          </a:p>
-        </p:txBody>
-      </p:sp>
-      <p:sp>
-        <p:nvSpPr>
-          <p:cNvPr id="18" name="Text 16"/>
-          <p:cNvSpPr/>
-          <p:nvPr/>
-        </p:nvSpPr>
-        <p:spPr>
-          <a:xfrm>
-            <a:off x="548640" y="4087368"/>
-            <a:ext cx="10524744" cy="384048"/>
-          </a:xfrm>
-          <a:prstGeom prst="rect">
-            <a:avLst/>
-          </a:prstGeom>
-          <a:noFill/>
-          <a:ln/>
-        </p:spPr>
-        <p:txBody>
-          <a:bodyPr wrap="square" rtlCol="0" anchor="t"/>
-          <a:lstStyle/>
-          <a:p>
-            <a:pPr rtl="1" algn="r" indent="0" marL="0">
-              <a:buNone/>
-            </a:pPr>
-            <a:r>
-              <a:rPr lang="en-US" sz="1700" b="1" dirty="0">
-                <a:solidFill>
-                  <a:srgbClr val="222232"/>
-                </a:solidFill>
-                <a:latin typeface="Arial" pitchFamily="34" charset="0"/>
-                <a:ea typeface="Arial" pitchFamily="34" charset="-122"/>
-                <a:cs typeface="Arial" pitchFamily="34" charset="-120"/>
-              </a:rPr>
-              <a:t>שאלו: האם הקוד מטפל ברשימה ריקה? האם הבנתם כל שורה?</a:t>
-            </a:r>
-            <a:endParaRPr lang="en-US" sz="1700" dirty="0"/>
-          </a:p>
-        </p:txBody>
-      </p:sp>
-      <p:sp>
-        <p:nvSpPr>
-          <p:cNvPr id="19" name="Shape 17"/>
-          <p:cNvSpPr/>
-          <p:nvPr/>
-        </p:nvSpPr>
-        <p:spPr>
-          <a:xfrm>
-            <a:off x="548640" y="4800600"/>
-            <a:ext cx="11091672" cy="960120"/>
+              <a:rPr lang="en-US" sz="1500" b="1" dirty="0">
+                <a:solidFill>
+                  <a:srgbClr val="1E2761"/>
+                </a:solidFill>
+                <a:latin typeface="Arial" pitchFamily="34" charset="0"/>
+                <a:ea typeface="Arial" pitchFamily="34" charset="-122"/>
+                <a:cs typeface="Arial" pitchFamily="34" charset="-120"/>
+              </a:rPr>
+              <a:t>הריצו את אותה משימה פעמיים באותו כלי — פעם בעברית, פעם באנגלית:</a:t>
+            </a:r>
+            <a:endParaRPr lang="en-US" sz="1500" dirty="0"/>
+          </a:p>
+        </p:txBody>
+      </p:sp>
+      <p:sp>
+        <p:nvSpPr>
+          <p:cNvPr id="5" name="Shape 3"/>
+          <p:cNvSpPr/>
+          <p:nvPr/>
+        </p:nvSpPr>
+        <p:spPr>
+          <a:xfrm>
+            <a:off x="6277356" y="2011680"/>
+            <a:ext cx="5362956" cy="1371600"/>
           </a:xfrm>
           <a:prstGeom prst="roundRect">
             <a:avLst>
-              <a:gd name="adj" fmla="val 7619"/>
+              <a:gd name="adj" fmla="val 5333"/>
             </a:avLst>
           </a:prstGeom>
           <a:solidFill>
@@ -14364,14 +14295,14 @@
       </p:sp>
       <p:sp>
         <p:nvSpPr>
-          <p:cNvPr id="20" name="Text 18"/>
-          <p:cNvSpPr/>
-          <p:nvPr/>
-        </p:nvSpPr>
-        <p:spPr>
-          <a:xfrm>
-            <a:off x="9811512" y="4892040"/>
-            <a:ext cx="1645920" cy="320040"/>
+          <p:cNvPr id="6" name="Text 4"/>
+          <p:cNvSpPr/>
+          <p:nvPr/>
+        </p:nvSpPr>
+        <p:spPr>
+          <a:xfrm>
+            <a:off x="6551676" y="2139696"/>
+            <a:ext cx="4814316" cy="292608"/>
           </a:xfrm>
           <a:prstGeom prst="rect">
             <a:avLst/>
@@ -14395,7 +14326,7 @@
                 <a:ea typeface="Arial" pitchFamily="34" charset="-122"/>
                 <a:cs typeface="Arial" pitchFamily="34" charset="-120"/>
               </a:rPr>
-              <a:t>הפרומפט:</a:t>
+              <a:t>עברית</a:t>
             </a:r>
             <a:endParaRPr lang="en-US" sz="1250" dirty="0"/>
           </a:p>
@@ -14403,14 +14334,14 @@
       </p:sp>
       <p:sp>
         <p:nvSpPr>
-          <p:cNvPr id="21" name="Text 19"/>
-          <p:cNvSpPr/>
-          <p:nvPr/>
-        </p:nvSpPr>
-        <p:spPr>
-          <a:xfrm>
-            <a:off x="822960" y="5212080"/>
-            <a:ext cx="10543032" cy="457200"/>
+          <p:cNvPr id="7" name="Text 5"/>
+          <p:cNvSpPr/>
+          <p:nvPr/>
+        </p:nvSpPr>
+        <p:spPr>
+          <a:xfrm>
+            <a:off x="6551676" y="2487168"/>
+            <a:ext cx="4814316" cy="822960"/>
           </a:xfrm>
           <a:prstGeom prst="rect">
             <a:avLst/>
@@ -14426,7 +14357,7 @@
               <a:buNone/>
             </a:pPr>
             <a:r>
-              <a:rPr lang="en-US" sz="1300" dirty="0">
+              <a:rPr lang="en-US" sz="1200" dirty="0">
                 <a:solidFill>
                   <a:srgbClr val="E8E8F0"/>
                 </a:solidFill>
@@ -14434,7 +14365,283 @@
                 <a:ea typeface="Arial" pitchFamily="34" charset="-122"/>
                 <a:cs typeface="Arial" pitchFamily="34" charset="-120"/>
               </a:rPr>
-              <a:t>“כתוב פונקציה בפייתון שמקבלת רשימת מספרים ומחזירה את הממוצע. הוסף טיפול ברשימה ריקה, והסבר בעברית מה הקוד עושה.”</a:t>
+              <a:t>“כתוב פונקציה בפייתון שמקבלת רשימת מספרים ומחזירה את הממוצע. הוסף טיפול ברשימה ריקה, והסבר מה הקוד עושה.”</a:t>
+            </a:r>
+            <a:endParaRPr lang="en-US" sz="1200" dirty="0"/>
+          </a:p>
+        </p:txBody>
+      </p:sp>
+      <p:sp>
+        <p:nvSpPr>
+          <p:cNvPr id="8" name="Shape 6"/>
+          <p:cNvSpPr/>
+          <p:nvPr/>
+        </p:nvSpPr>
+        <p:spPr>
+          <a:xfrm>
+            <a:off x="548640" y="2011680"/>
+            <a:ext cx="5362956" cy="1371600"/>
+          </a:xfrm>
+          <a:prstGeom prst="roundRect">
+            <a:avLst>
+              <a:gd name="adj" fmla="val 5333"/>
+            </a:avLst>
+          </a:prstGeom>
+          <a:solidFill>
+            <a:srgbClr val="1B1B2B"/>
+          </a:solidFill>
+          <a:ln/>
+          <a:effectLst>
+            <a:outerShdw sx="100000" sy="100000" kx="0" ky="0" algn="bl" rotWithShape="0" blurRad="76200" dist="25400" dir="5400000">
+              <a:srgbClr val="999999">
+                <a:alpha val="28000"/>
+              </a:srgbClr>
+            </a:outerShdw>
+          </a:effectLst>
+        </p:spPr>
+      </p:sp>
+      <p:sp>
+        <p:nvSpPr>
+          <p:cNvPr id="9" name="Text 7"/>
+          <p:cNvSpPr/>
+          <p:nvPr/>
+        </p:nvSpPr>
+        <p:spPr>
+          <a:xfrm>
+            <a:off x="822960" y="2139696"/>
+            <a:ext cx="4814316" cy="292608"/>
+          </a:xfrm>
+          <a:prstGeom prst="rect">
+            <a:avLst/>
+          </a:prstGeom>
+          <a:noFill/>
+          <a:ln/>
+        </p:spPr>
+        <p:txBody>
+          <a:bodyPr wrap="square" rtlCol="0" anchor="ctr"/>
+          <a:lstStyle/>
+          <a:p>
+            <a:pPr algn="l" indent="0" marL="0">
+              <a:buNone/>
+            </a:pPr>
+            <a:r>
+              <a:rPr lang="en-US" sz="1250" b="1" dirty="0">
+                <a:solidFill>
+                  <a:srgbClr val="0E9AA7"/>
+                </a:solidFill>
+                <a:latin typeface="Arial" pitchFamily="34" charset="0"/>
+                <a:ea typeface="Arial" pitchFamily="34" charset="-122"/>
+                <a:cs typeface="Arial" pitchFamily="34" charset="-120"/>
+              </a:rPr>
+              <a:t>English</a:t>
+            </a:r>
+            <a:endParaRPr lang="en-US" sz="1250" dirty="0"/>
+          </a:p>
+        </p:txBody>
+      </p:sp>
+      <p:sp>
+        <p:nvSpPr>
+          <p:cNvPr id="10" name="Text 8"/>
+          <p:cNvSpPr/>
+          <p:nvPr/>
+        </p:nvSpPr>
+        <p:spPr>
+          <a:xfrm>
+            <a:off x="822960" y="2487168"/>
+            <a:ext cx="4814316" cy="822960"/>
+          </a:xfrm>
+          <a:prstGeom prst="rect">
+            <a:avLst/>
+          </a:prstGeom>
+          <a:noFill/>
+          <a:ln/>
+        </p:spPr>
+        <p:txBody>
+          <a:bodyPr wrap="square" rtlCol="0" anchor="ctr"/>
+          <a:lstStyle/>
+          <a:p>
+            <a:pPr algn="l" indent="0" marL="0">
+              <a:buNone/>
+            </a:pPr>
+            <a:r>
+              <a:rPr lang="en-US" sz="1200" dirty="0">
+                <a:solidFill>
+                  <a:srgbClr val="E8E8F0"/>
+                </a:solidFill>
+                <a:latin typeface="Arial" pitchFamily="34" charset="0"/>
+                <a:ea typeface="Arial" pitchFamily="34" charset="-122"/>
+                <a:cs typeface="Arial" pitchFamily="34" charset="-120"/>
+              </a:rPr>
+              <a:t>“Write a Python function that takes a list of numbers and returns the average. Handle the empty-list case, and explain what the code does.”</a:t>
+            </a:r>
+            <a:endParaRPr lang="en-US" sz="1200" dirty="0"/>
+          </a:p>
+        </p:txBody>
+      </p:sp>
+      <p:sp>
+        <p:nvSpPr>
+          <p:cNvPr id="11" name="Shape 9"/>
+          <p:cNvSpPr/>
+          <p:nvPr/>
+        </p:nvSpPr>
+        <p:spPr>
+          <a:xfrm>
+            <a:off x="548640" y="3566160"/>
+            <a:ext cx="11091672" cy="1417320"/>
+          </a:xfrm>
+          <a:prstGeom prst="roundRect">
+            <a:avLst>
+              <a:gd name="adj" fmla="val 5806"/>
+            </a:avLst>
+          </a:prstGeom>
+          <a:solidFill>
+            <a:srgbClr val="F2F3FA"/>
+          </a:solidFill>
+          <a:ln/>
+          <a:effectLst>
+            <a:outerShdw sx="100000" sy="100000" kx="0" ky="0" algn="bl" rotWithShape="0" blurRad="76200" dist="25400" dir="5400000">
+              <a:srgbClr val="999999">
+                <a:alpha val="28000"/>
+              </a:srgbClr>
+            </a:outerShdw>
+          </a:effectLst>
+        </p:spPr>
+      </p:sp>
+      <p:sp>
+        <p:nvSpPr>
+          <p:cNvPr id="12" name="Text 10"/>
+          <p:cNvSpPr/>
+          <p:nvPr/>
+        </p:nvSpPr>
+        <p:spPr>
+          <a:xfrm>
+            <a:off x="10085832" y="3657600"/>
+            <a:ext cx="1371600" cy="320040"/>
+          </a:xfrm>
+          <a:prstGeom prst="rect">
+            <a:avLst/>
+          </a:prstGeom>
+          <a:noFill/>
+          <a:ln/>
+        </p:spPr>
+        <p:txBody>
+          <a:bodyPr wrap="square" rtlCol="0" anchor="t"/>
+          <a:lstStyle/>
+          <a:p>
+            <a:pPr rtl="1" algn="r" indent="0" marL="0">
+              <a:buNone/>
+            </a:pPr>
+            <a:r>
+              <a:rPr lang="en-US" sz="1400" b="1" dirty="0">
+                <a:solidFill>
+                  <a:srgbClr val="1E2761"/>
+                </a:solidFill>
+                <a:latin typeface="Arial" pitchFamily="34" charset="0"/>
+                <a:ea typeface="Arial" pitchFamily="34" charset="-122"/>
+                <a:cs typeface="Arial" pitchFamily="34" charset="-120"/>
+              </a:rPr>
+              <a:t>מה לבדוק:</a:t>
+            </a:r>
+            <a:endParaRPr lang="en-US" sz="1400" dirty="0"/>
+          </a:p>
+        </p:txBody>
+      </p:sp>
+      <p:sp>
+        <p:nvSpPr>
+          <p:cNvPr id="13" name="Text 11"/>
+          <p:cNvSpPr/>
+          <p:nvPr/>
+        </p:nvSpPr>
+        <p:spPr>
+          <a:xfrm>
+            <a:off x="868680" y="4041648"/>
+            <a:ext cx="10451592" cy="868680"/>
+          </a:xfrm>
+          <a:prstGeom prst="rect">
+            <a:avLst/>
+          </a:prstGeom>
+          <a:noFill/>
+          <a:ln/>
+        </p:spPr>
+        <p:txBody>
+          <a:bodyPr wrap="square" rtlCol="0" anchor="t"/>
+          <a:lstStyle/>
+          <a:p>
+            <a:pPr rtl="1" algn="r" indent="0" marL="0">
+              <a:lnSpc>
+                <a:spcPct val="130000"/>
+              </a:lnSpc>
+              <a:buNone/>
+            </a:pPr>
+            <a:r>
+              <a:rPr lang="en-US" sz="1350" dirty="0">
+                <a:solidFill>
+                  <a:srgbClr val="222232"/>
+                </a:solidFill>
+                <a:latin typeface="Arial" pitchFamily="34" charset="0"/>
+                <a:ea typeface="Arial" pitchFamily="34" charset="-122"/>
+                <a:cs typeface="Arial" pitchFamily="34" charset="-120"/>
+              </a:rPr>
+              <a:t>•  האם הקוד זהה?   •  מי טיפל במקרה הקצה?   •  איזה הסבר מפורט יותר?</a:t>
+            </a:r>
+            <a:endParaRPr lang="en-US" sz="1350" dirty="0"/>
+          </a:p>
+          <a:p>
+            <a:pPr rtl="1" algn="r" indent="0" marL="0">
+              <a:lnSpc>
+                <a:spcPct val="130000"/>
+              </a:lnSpc>
+              <a:buNone/>
+            </a:pPr>
+            <a:r>
+              <a:rPr lang="en-US" sz="1350" dirty="0">
+                <a:solidFill>
+                  <a:srgbClr val="222232"/>
+                </a:solidFill>
+                <a:latin typeface="Arial" pitchFamily="34" charset="0"/>
+                <a:ea typeface="Arial" pitchFamily="34" charset="-122"/>
+                <a:cs typeface="Arial" pitchFamily="34" charset="-120"/>
+              </a:rPr>
+              <a:t>•  באיזו שפה נכתבו ההערות בקוד?   •  איזו שפה נתנה תוצאה טובה יותר?</a:t>
+            </a:r>
+            <a:endParaRPr lang="en-US" sz="1350" dirty="0"/>
+          </a:p>
+        </p:txBody>
+      </p:sp>
+      <p:sp>
+        <p:nvSpPr>
+          <p:cNvPr id="14" name="Text 12"/>
+          <p:cNvSpPr/>
+          <p:nvPr/>
+        </p:nvSpPr>
+        <p:spPr>
+          <a:xfrm>
+            <a:off x="548640" y="5120640"/>
+            <a:ext cx="11091672" cy="365760"/>
+          </a:xfrm>
+          <a:prstGeom prst="rect">
+            <a:avLst/>
+          </a:prstGeom>
+          <a:noFill/>
+          <a:ln/>
+        </p:spPr>
+        <p:txBody>
+          <a:bodyPr wrap="square" rtlCol="0" anchor="t"/>
+          <a:lstStyle/>
+          <a:p>
+            <a:pPr rtl="1" algn="r" indent="0" marL="0">
+              <a:buNone/>
+            </a:pPr>
+            <a:r>
+              <a:rPr lang="en-US" sz="1300" i="1" dirty="0">
+                <a:solidFill>
+                  <a:srgbClr val="6B6B80"/>
+                </a:solidFill>
+                <a:latin typeface="Arial" pitchFamily="34" charset="0"/>
+                <a:ea typeface="Arial" pitchFamily="34" charset="-122"/>
+                <a:cs typeface="Arial" pitchFamily="34" charset="-120"/>
+              </a:rPr>
+              <a:t>רקע: מודלים רבים אומנו בעיקר על אנגלית — ייתכנו הבדלים. בדקו בעצמכם, אל תניחו מראש.</a:t>
             </a:r>
             <a:endParaRPr lang="en-US" sz="1300" dirty="0"/>
           </a:p>
@@ -14442,7 +14649,7 @@
       </p:sp>
       <p:sp>
         <p:nvSpPr>
-          <p:cNvPr id="22" name="Text 20"/>
+          <p:cNvPr id="15" name="Text 13"/>
           <p:cNvSpPr/>
           <p:nvPr/>
         </p:nvSpPr>
@@ -14473,7 +14680,7 @@
                 <a:ea typeface="Arial" pitchFamily="34" charset="-122"/>
                 <a:cs typeface="Arial" pitchFamily="34" charset="-120"/>
               </a:rPr>
-              <a:t>24 / 26</a:t>
+              <a:t>24 / 27</a:t>
             </a:r>
             <a:endParaRPr lang="en-US" sz="950" dirty="0"/>
           </a:p>
@@ -14481,7 +14688,7 @@
       </p:sp>
       <p:sp>
         <p:nvSpPr>
-          <p:cNvPr id="23" name="Text 21"/>
+          <p:cNvPr id="16" name="Text 14"/>
           <p:cNvSpPr/>
           <p:nvPr/>
         </p:nvSpPr>
@@ -14583,7 +14790,7 @@
                 <a:ea typeface="Arial" pitchFamily="34" charset="-122"/>
                 <a:cs typeface="Arial" pitchFamily="34" charset="-120"/>
               </a:rPr>
-              <a:t>הגשה</a:t>
+              <a:t>אימות בהרצה (10 דקות)</a:t>
             </a:r>
             <a:endParaRPr lang="en-US" sz="1250" dirty="0"/>
           </a:p>
@@ -14622,7 +14829,7 @@
                 <a:ea typeface="Arial" pitchFamily="34" charset="-122"/>
                 <a:cs typeface="Arial" pitchFamily="34" charset="-120"/>
               </a:rPr>
-              <a:t>קריטריוני הצלחה ותוצר</a:t>
+              <a:t>הריצו בפועל — כולל מקרה קצה</a:t>
             </a:r>
             <a:endParaRPr lang="en-US" sz="3300" dirty="0"/>
           </a:p>
@@ -14636,16 +14843,408 @@
         </p:nvSpPr>
         <p:spPr>
           <a:xfrm>
-            <a:off x="6277356" y="1737360"/>
-            <a:ext cx="5362956" cy="1965960"/>
+            <a:off x="11228832" y="1783080"/>
+            <a:ext cx="411480" cy="411480"/>
+          </a:xfrm>
+          <a:prstGeom prst="ellipse">
+            <a:avLst/>
+          </a:prstGeom>
+          <a:solidFill>
+            <a:srgbClr val="3B3B98"/>
+          </a:solidFill>
+          <a:ln/>
+        </p:spPr>
+      </p:sp>
+      <p:sp>
+        <p:nvSpPr>
+          <p:cNvPr id="5" name="Text 3"/>
+          <p:cNvSpPr/>
+          <p:nvPr/>
+        </p:nvSpPr>
+        <p:spPr>
+          <a:xfrm>
+            <a:off x="11228832" y="1783080"/>
+            <a:ext cx="411480" cy="411480"/>
+          </a:xfrm>
+          <a:prstGeom prst="rect">
+            <a:avLst/>
+          </a:prstGeom>
+          <a:noFill/>
+          <a:ln/>
+        </p:spPr>
+        <p:txBody>
+          <a:bodyPr wrap="square" rtlCol="0" anchor="ctr"/>
+          <a:lstStyle/>
+          <a:p>
+            <a:pPr algn="ctr" indent="0" marL="0">
+              <a:buNone/>
+            </a:pPr>
+            <a:r>
+              <a:rPr lang="en-US" sz="1600" b="1" dirty="0">
+                <a:solidFill>
+                  <a:srgbClr val="FFFFFF"/>
+                </a:solidFill>
+                <a:latin typeface="Arial" pitchFamily="34" charset="0"/>
+                <a:ea typeface="Arial" pitchFamily="34" charset="-122"/>
+                <a:cs typeface="Arial" pitchFamily="34" charset="-120"/>
+              </a:rPr>
+              <a:t>1</a:t>
+            </a:r>
+            <a:endParaRPr lang="en-US" sz="1600" dirty="0"/>
+          </a:p>
+        </p:txBody>
+      </p:sp>
+      <p:sp>
+        <p:nvSpPr>
+          <p:cNvPr id="6" name="Text 4"/>
+          <p:cNvSpPr/>
+          <p:nvPr/>
+        </p:nvSpPr>
+        <p:spPr>
+          <a:xfrm>
+            <a:off x="548640" y="1764792"/>
+            <a:ext cx="10515600" cy="384048"/>
+          </a:xfrm>
+          <a:prstGeom prst="rect">
+            <a:avLst/>
+          </a:prstGeom>
+          <a:noFill/>
+          <a:ln/>
+        </p:spPr>
+        <p:txBody>
+          <a:bodyPr wrap="square" rtlCol="0" anchor="t"/>
+          <a:lstStyle/>
+          <a:p>
+            <a:pPr rtl="1" algn="r" indent="0" marL="0">
+              <a:buNone/>
+            </a:pPr>
+            <a:r>
+              <a:rPr lang="en-US" sz="1700" b="1" dirty="0">
+                <a:solidFill>
+                  <a:srgbClr val="222232"/>
+                </a:solidFill>
+                <a:latin typeface="Arial" pitchFamily="34" charset="0"/>
+                <a:ea typeface="Arial" pitchFamily="34" charset="-122"/>
+                <a:cs typeface="Arial" pitchFamily="34" charset="-120"/>
+              </a:rPr>
+              <a:t>פתחו Google Colab (חינמי, בדפדפן) והדביקו את הקוד.</a:t>
+            </a:r>
+            <a:endParaRPr lang="en-US" sz="1700" dirty="0"/>
+          </a:p>
+        </p:txBody>
+      </p:sp>
+      <p:sp>
+        <p:nvSpPr>
+          <p:cNvPr id="7" name="Shape 5"/>
+          <p:cNvSpPr/>
+          <p:nvPr/>
+        </p:nvSpPr>
+        <p:spPr>
+          <a:xfrm>
+            <a:off x="11228832" y="2468880"/>
+            <a:ext cx="411480" cy="411480"/>
+          </a:xfrm>
+          <a:prstGeom prst="ellipse">
+            <a:avLst/>
+          </a:prstGeom>
+          <a:solidFill>
+            <a:srgbClr val="3B3B98"/>
+          </a:solidFill>
+          <a:ln/>
+        </p:spPr>
+      </p:sp>
+      <p:sp>
+        <p:nvSpPr>
+          <p:cNvPr id="8" name="Text 6"/>
+          <p:cNvSpPr/>
+          <p:nvPr/>
+        </p:nvSpPr>
+        <p:spPr>
+          <a:xfrm>
+            <a:off x="11228832" y="2468880"/>
+            <a:ext cx="411480" cy="411480"/>
+          </a:xfrm>
+          <a:prstGeom prst="rect">
+            <a:avLst/>
+          </a:prstGeom>
+          <a:noFill/>
+          <a:ln/>
+        </p:spPr>
+        <p:txBody>
+          <a:bodyPr wrap="square" rtlCol="0" anchor="ctr"/>
+          <a:lstStyle/>
+          <a:p>
+            <a:pPr algn="ctr" indent="0" marL="0">
+              <a:buNone/>
+            </a:pPr>
+            <a:r>
+              <a:rPr lang="en-US" sz="1600" b="1" dirty="0">
+                <a:solidFill>
+                  <a:srgbClr val="FFFFFF"/>
+                </a:solidFill>
+                <a:latin typeface="Arial" pitchFamily="34" charset="0"/>
+                <a:ea typeface="Arial" pitchFamily="34" charset="-122"/>
+                <a:cs typeface="Arial" pitchFamily="34" charset="-120"/>
+              </a:rPr>
+              <a:t>2</a:t>
+            </a:r>
+            <a:endParaRPr lang="en-US" sz="1600" dirty="0"/>
+          </a:p>
+        </p:txBody>
+      </p:sp>
+      <p:sp>
+        <p:nvSpPr>
+          <p:cNvPr id="9" name="Text 7"/>
+          <p:cNvSpPr/>
+          <p:nvPr/>
+        </p:nvSpPr>
+        <p:spPr>
+          <a:xfrm>
+            <a:off x="548640" y="2450592"/>
+            <a:ext cx="10515600" cy="384048"/>
+          </a:xfrm>
+          <a:prstGeom prst="rect">
+            <a:avLst/>
+          </a:prstGeom>
+          <a:noFill/>
+          <a:ln/>
+        </p:spPr>
+        <p:txBody>
+          <a:bodyPr wrap="square" rtlCol="0" anchor="t"/>
+          <a:lstStyle/>
+          <a:p>
+            <a:pPr rtl="1" algn="r" indent="0" marL="0">
+              <a:buNone/>
+            </a:pPr>
+            <a:r>
+              <a:rPr lang="en-US" sz="1700" b="1" dirty="0">
+                <a:solidFill>
+                  <a:srgbClr val="222232"/>
+                </a:solidFill>
+                <a:latin typeface="Arial" pitchFamily="34" charset="0"/>
+                <a:ea typeface="Arial" pitchFamily="34" charset="-122"/>
+                <a:cs typeface="Arial" pitchFamily="34" charset="-120"/>
+              </a:rPr>
+              <a:t>הריצו עם רשימה רגילה: [10, 20, 30]  →  אמור להחזיר 20.</a:t>
+            </a:r>
+            <a:endParaRPr lang="en-US" sz="1700" dirty="0"/>
+          </a:p>
+        </p:txBody>
+      </p:sp>
+      <p:sp>
+        <p:nvSpPr>
+          <p:cNvPr id="10" name="Shape 8"/>
+          <p:cNvSpPr/>
+          <p:nvPr/>
+        </p:nvSpPr>
+        <p:spPr>
+          <a:xfrm>
+            <a:off x="11228832" y="3154680"/>
+            <a:ext cx="411480" cy="411480"/>
+          </a:xfrm>
+          <a:prstGeom prst="ellipse">
+            <a:avLst/>
+          </a:prstGeom>
+          <a:solidFill>
+            <a:srgbClr val="3B3B98"/>
+          </a:solidFill>
+          <a:ln/>
+        </p:spPr>
+      </p:sp>
+      <p:sp>
+        <p:nvSpPr>
+          <p:cNvPr id="11" name="Text 9"/>
+          <p:cNvSpPr/>
+          <p:nvPr/>
+        </p:nvSpPr>
+        <p:spPr>
+          <a:xfrm>
+            <a:off x="11228832" y="3154680"/>
+            <a:ext cx="411480" cy="411480"/>
+          </a:xfrm>
+          <a:prstGeom prst="rect">
+            <a:avLst/>
+          </a:prstGeom>
+          <a:noFill/>
+          <a:ln/>
+        </p:spPr>
+        <p:txBody>
+          <a:bodyPr wrap="square" rtlCol="0" anchor="ctr"/>
+          <a:lstStyle/>
+          <a:p>
+            <a:pPr algn="ctr" indent="0" marL="0">
+              <a:buNone/>
+            </a:pPr>
+            <a:r>
+              <a:rPr lang="en-US" sz="1600" b="1" dirty="0">
+                <a:solidFill>
+                  <a:srgbClr val="FFFFFF"/>
+                </a:solidFill>
+                <a:latin typeface="Arial" pitchFamily="34" charset="0"/>
+                <a:ea typeface="Arial" pitchFamily="34" charset="-122"/>
+                <a:cs typeface="Arial" pitchFamily="34" charset="-120"/>
+              </a:rPr>
+              <a:t>3</a:t>
+            </a:r>
+            <a:endParaRPr lang="en-US" sz="1600" dirty="0"/>
+          </a:p>
+        </p:txBody>
+      </p:sp>
+      <p:sp>
+        <p:nvSpPr>
+          <p:cNvPr id="12" name="Text 10"/>
+          <p:cNvSpPr/>
+          <p:nvPr/>
+        </p:nvSpPr>
+        <p:spPr>
+          <a:xfrm>
+            <a:off x="548640" y="3136392"/>
+            <a:ext cx="10515600" cy="384048"/>
+          </a:xfrm>
+          <a:prstGeom prst="rect">
+            <a:avLst/>
+          </a:prstGeom>
+          <a:noFill/>
+          <a:ln/>
+        </p:spPr>
+        <p:txBody>
+          <a:bodyPr wrap="square" rtlCol="0" anchor="t"/>
+          <a:lstStyle/>
+          <a:p>
+            <a:pPr rtl="1" algn="r" indent="0" marL="0">
+              <a:buNone/>
+            </a:pPr>
+            <a:r>
+              <a:rPr lang="en-US" sz="1700" b="1" dirty="0">
+                <a:solidFill>
+                  <a:srgbClr val="222232"/>
+                </a:solidFill>
+                <a:latin typeface="Arial" pitchFamily="34" charset="0"/>
+                <a:ea typeface="Arial" pitchFamily="34" charset="-122"/>
+                <a:cs typeface="Arial" pitchFamily="34" charset="-120"/>
+              </a:rPr>
+              <a:t>הריצו שוב עם רשימה ריקה: [ ]  →  כאן מתגלה ההבדל.</a:t>
+            </a:r>
+            <a:endParaRPr lang="en-US" sz="1700" dirty="0"/>
+          </a:p>
+        </p:txBody>
+      </p:sp>
+      <p:sp>
+        <p:nvSpPr>
+          <p:cNvPr id="13" name="Shape 11"/>
+          <p:cNvSpPr/>
+          <p:nvPr/>
+        </p:nvSpPr>
+        <p:spPr>
+          <a:xfrm>
+            <a:off x="11228832" y="3840480"/>
+            <a:ext cx="411480" cy="411480"/>
+          </a:xfrm>
+          <a:prstGeom prst="ellipse">
+            <a:avLst/>
+          </a:prstGeom>
+          <a:solidFill>
+            <a:srgbClr val="3B3B98"/>
+          </a:solidFill>
+          <a:ln/>
+        </p:spPr>
+      </p:sp>
+      <p:sp>
+        <p:nvSpPr>
+          <p:cNvPr id="14" name="Text 12"/>
+          <p:cNvSpPr/>
+          <p:nvPr/>
+        </p:nvSpPr>
+        <p:spPr>
+          <a:xfrm>
+            <a:off x="11228832" y="3840480"/>
+            <a:ext cx="411480" cy="411480"/>
+          </a:xfrm>
+          <a:prstGeom prst="rect">
+            <a:avLst/>
+          </a:prstGeom>
+          <a:noFill/>
+          <a:ln/>
+        </p:spPr>
+        <p:txBody>
+          <a:bodyPr wrap="square" rtlCol="0" anchor="ctr"/>
+          <a:lstStyle/>
+          <a:p>
+            <a:pPr algn="ctr" indent="0" marL="0">
+              <a:buNone/>
+            </a:pPr>
+            <a:r>
+              <a:rPr lang="en-US" sz="1600" b="1" dirty="0">
+                <a:solidFill>
+                  <a:srgbClr val="FFFFFF"/>
+                </a:solidFill>
+                <a:latin typeface="Arial" pitchFamily="34" charset="0"/>
+                <a:ea typeface="Arial" pitchFamily="34" charset="-122"/>
+                <a:cs typeface="Arial" pitchFamily="34" charset="-120"/>
+              </a:rPr>
+              <a:t>4</a:t>
+            </a:r>
+            <a:endParaRPr lang="en-US" sz="1600" dirty="0"/>
+          </a:p>
+        </p:txBody>
+      </p:sp>
+      <p:sp>
+        <p:nvSpPr>
+          <p:cNvPr id="15" name="Text 13"/>
+          <p:cNvSpPr/>
+          <p:nvPr/>
+        </p:nvSpPr>
+        <p:spPr>
+          <a:xfrm>
+            <a:off x="548640" y="3822192"/>
+            <a:ext cx="10515600" cy="384048"/>
+          </a:xfrm>
+          <a:prstGeom prst="rect">
+            <a:avLst/>
+          </a:prstGeom>
+          <a:noFill/>
+          <a:ln/>
+        </p:spPr>
+        <p:txBody>
+          <a:bodyPr wrap="square" rtlCol="0" anchor="t"/>
+          <a:lstStyle/>
+          <a:p>
+            <a:pPr rtl="1" algn="r" indent="0" marL="0">
+              <a:buNone/>
+            </a:pPr>
+            <a:r>
+              <a:rPr lang="en-US" sz="1700" b="1" dirty="0">
+                <a:solidFill>
+                  <a:srgbClr val="222232"/>
+                </a:solidFill>
+                <a:latin typeface="Arial" pitchFamily="34" charset="0"/>
+                <a:ea typeface="Arial" pitchFamily="34" charset="-122"/>
+                <a:cs typeface="Arial" pitchFamily="34" charset="-120"/>
+              </a:rPr>
+              <a:t>רשמו: איזה פלט נפל בשגיאה, ואיזה טיפל נכון.</a:t>
+            </a:r>
+            <a:endParaRPr lang="en-US" sz="1700" dirty="0"/>
+          </a:p>
+        </p:txBody>
+      </p:sp>
+      <p:sp>
+        <p:nvSpPr>
+          <p:cNvPr id="16" name="Shape 14"/>
+          <p:cNvSpPr/>
+          <p:nvPr/>
+        </p:nvSpPr>
+        <p:spPr>
+          <a:xfrm>
+            <a:off x="548640" y="4709160"/>
+            <a:ext cx="11091672" cy="960120"/>
           </a:xfrm>
           <a:prstGeom prst="roundRect">
             <a:avLst>
-              <a:gd name="adj" fmla="val 4186"/>
+              <a:gd name="adj" fmla="val 9524"/>
             </a:avLst>
           </a:prstGeom>
           <a:solidFill>
-            <a:srgbClr val="EAF3EA"/>
+            <a:srgbClr val="1E2761"/>
           </a:solidFill>
           <a:ln/>
           <a:effectLst>
@@ -14659,271 +15258,14 @@
       </p:sp>
       <p:sp>
         <p:nvSpPr>
-          <p:cNvPr id="5" name="Text 3"/>
-          <p:cNvSpPr/>
-          <p:nvPr/>
-        </p:nvSpPr>
-        <p:spPr>
-          <a:xfrm>
-            <a:off x="6551676" y="1920240"/>
-            <a:ext cx="4814316" cy="365760"/>
-          </a:xfrm>
-          <a:prstGeom prst="rect">
-            <a:avLst/>
-          </a:prstGeom>
-          <a:noFill/>
-          <a:ln/>
-        </p:spPr>
-        <p:txBody>
-          <a:bodyPr wrap="square" rtlCol="0" anchor="t"/>
-          <a:lstStyle/>
-          <a:p>
-            <a:pPr rtl="1" algn="r" indent="0" marL="0">
-              <a:buNone/>
-            </a:pPr>
-            <a:r>
-              <a:rPr lang="en-US" sz="1500" b="1" dirty="0">
-                <a:solidFill>
-                  <a:srgbClr val="2E7D32"/>
-                </a:solidFill>
-                <a:latin typeface="Arial" pitchFamily="34" charset="0"/>
-                <a:ea typeface="Arial" pitchFamily="34" charset="-122"/>
-                <a:cs typeface="Arial" pitchFamily="34" charset="-120"/>
-              </a:rPr>
-              <a:t>הצלחתם אם...</a:t>
-            </a:r>
-            <a:endParaRPr lang="en-US" sz="1500" dirty="0"/>
-          </a:p>
-        </p:txBody>
-      </p:sp>
-      <p:sp>
-        <p:nvSpPr>
-          <p:cNvPr id="6" name="Text 4"/>
-          <p:cNvSpPr/>
-          <p:nvPr/>
-        </p:nvSpPr>
-        <p:spPr>
-          <a:xfrm>
-            <a:off x="6551676" y="2395728"/>
-            <a:ext cx="4814316" cy="1188720"/>
-          </a:xfrm>
-          <a:prstGeom prst="rect">
-            <a:avLst/>
-          </a:prstGeom>
-          <a:noFill/>
-          <a:ln/>
-        </p:spPr>
-        <p:txBody>
-          <a:bodyPr wrap="square" rtlCol="0" anchor="t"/>
-          <a:lstStyle/>
-          <a:p>
-            <a:pPr rtl="1" algn="r" indent="0" marL="0">
-              <a:lnSpc>
-                <a:spcPct val="135000"/>
-              </a:lnSpc>
-              <a:buNone/>
-            </a:pPr>
-            <a:r>
-              <a:rPr lang="en-US" sz="1450" dirty="0">
-                <a:solidFill>
-                  <a:srgbClr val="222232"/>
-                </a:solidFill>
-                <a:latin typeface="Arial" pitchFamily="34" charset="0"/>
-                <a:ea typeface="Arial" pitchFamily="34" charset="-122"/>
-                <a:cs typeface="Arial" pitchFamily="34" charset="-120"/>
-              </a:rPr>
-              <a:t>✓  הרצתם את הפרומפט ב-2 כלים</a:t>
-            </a:r>
-            <a:endParaRPr lang="en-US" sz="1450" dirty="0"/>
-          </a:p>
-          <a:p>
-            <a:pPr rtl="1" algn="r" indent="0" marL="0">
-              <a:lnSpc>
-                <a:spcPct val="135000"/>
-              </a:lnSpc>
-              <a:buNone/>
-            </a:pPr>
-            <a:r>
-              <a:rPr lang="en-US" sz="1450" dirty="0">
-                <a:solidFill>
-                  <a:srgbClr val="222232"/>
-                </a:solidFill>
-                <a:latin typeface="Arial" pitchFamily="34" charset="0"/>
-                <a:ea typeface="Arial" pitchFamily="34" charset="-122"/>
-                <a:cs typeface="Arial" pitchFamily="34" charset="-120"/>
-              </a:rPr>
-              <a:t>✓  הרצתם בפועל את הקוד שהתקבל</a:t>
-            </a:r>
-            <a:endParaRPr lang="en-US" sz="1450" dirty="0"/>
-          </a:p>
-          <a:p>
-            <a:pPr rtl="1" algn="r" indent="0" marL="0">
-              <a:lnSpc>
-                <a:spcPct val="135000"/>
-              </a:lnSpc>
-              <a:buNone/>
-            </a:pPr>
-            <a:r>
-              <a:rPr lang="en-US" sz="1450" dirty="0">
-                <a:solidFill>
-                  <a:srgbClr val="222232"/>
-                </a:solidFill>
-                <a:latin typeface="Arial" pitchFamily="34" charset="0"/>
-                <a:ea typeface="Arial" pitchFamily="34" charset="-122"/>
-                <a:cs typeface="Arial" pitchFamily="34" charset="-120"/>
-              </a:rPr>
-              <a:t>✓  זיהיתם לפחות הבדל אחד בין הכלים</a:t>
-            </a:r>
-            <a:endParaRPr lang="en-US" sz="1450" dirty="0"/>
-          </a:p>
-        </p:txBody>
-      </p:sp>
-      <p:sp>
-        <p:nvSpPr>
-          <p:cNvPr id="7" name="Shape 5"/>
-          <p:cNvSpPr/>
-          <p:nvPr/>
-        </p:nvSpPr>
-        <p:spPr>
-          <a:xfrm>
-            <a:off x="548640" y="1737360"/>
-            <a:ext cx="5362956" cy="1965960"/>
-          </a:xfrm>
-          <a:prstGeom prst="roundRect">
-            <a:avLst>
-              <a:gd name="adj" fmla="val 4186"/>
-            </a:avLst>
-          </a:prstGeom>
-          <a:solidFill>
-            <a:srgbClr val="F2F3FA"/>
-          </a:solidFill>
-          <a:ln/>
-          <a:effectLst>
-            <a:outerShdw sx="100000" sy="100000" kx="0" ky="0" algn="bl" rotWithShape="0" blurRad="76200" dist="25400" dir="5400000">
-              <a:srgbClr val="999999">
-                <a:alpha val="28000"/>
-              </a:srgbClr>
-            </a:outerShdw>
-          </a:effectLst>
-        </p:spPr>
-      </p:sp>
-      <p:sp>
-        <p:nvSpPr>
-          <p:cNvPr id="8" name="Text 6"/>
-          <p:cNvSpPr/>
-          <p:nvPr/>
-        </p:nvSpPr>
-        <p:spPr>
-          <a:xfrm>
-            <a:off x="822960" y="1920240"/>
-            <a:ext cx="4814316" cy="365760"/>
-          </a:xfrm>
-          <a:prstGeom prst="rect">
-            <a:avLst/>
-          </a:prstGeom>
-          <a:noFill/>
-          <a:ln/>
-        </p:spPr>
-        <p:txBody>
-          <a:bodyPr wrap="square" rtlCol="0" anchor="t"/>
-          <a:lstStyle/>
-          <a:p>
-            <a:pPr rtl="1" algn="r" indent="0" marL="0">
-              <a:buNone/>
-            </a:pPr>
-            <a:r>
-              <a:rPr lang="en-US" sz="1500" b="1" dirty="0">
-                <a:solidFill>
-                  <a:srgbClr val="1E2761"/>
-                </a:solidFill>
-                <a:latin typeface="Arial" pitchFamily="34" charset="0"/>
-                <a:ea typeface="Arial" pitchFamily="34" charset="-122"/>
-                <a:cs typeface="Arial" pitchFamily="34" charset="-120"/>
-              </a:rPr>
-              <a:t>תוצר להגשה</a:t>
-            </a:r>
-            <a:endParaRPr lang="en-US" sz="1500" dirty="0"/>
-          </a:p>
-        </p:txBody>
-      </p:sp>
-      <p:sp>
-        <p:nvSpPr>
-          <p:cNvPr id="9" name="Text 7"/>
-          <p:cNvSpPr/>
-          <p:nvPr/>
-        </p:nvSpPr>
-        <p:spPr>
-          <a:xfrm>
-            <a:off x="822960" y="2395728"/>
-            <a:ext cx="4814316" cy="1188720"/>
-          </a:xfrm>
-          <a:prstGeom prst="rect">
-            <a:avLst/>
-          </a:prstGeom>
-          <a:noFill/>
-          <a:ln/>
-        </p:spPr>
-        <p:txBody>
-          <a:bodyPr wrap="square" rtlCol="0" anchor="t"/>
-          <a:lstStyle/>
-          <a:p>
-            <a:pPr rtl="1" algn="r" indent="0" marL="0">
-              <a:buNone/>
-            </a:pPr>
-            <a:r>
-              <a:rPr lang="en-US" sz="1450" dirty="0">
-                <a:solidFill>
-                  <a:srgbClr val="222232"/>
-                </a:solidFill>
-                <a:latin typeface="Arial" pitchFamily="34" charset="0"/>
-                <a:ea typeface="Arial" pitchFamily="34" charset="-122"/>
-                <a:cs typeface="Arial" pitchFamily="34" charset="-120"/>
-              </a:rPr>
-              <a:t>דוח קצר (חצי עמוד): באילו כלים השתמשתם, מה עבד, מה לא, ואיזה קוד הבנתם — ואיזה לא.</a:t>
-            </a:r>
-            <a:endParaRPr lang="en-US" sz="1450" dirty="0"/>
-          </a:p>
-        </p:txBody>
-      </p:sp>
-      <p:sp>
-        <p:nvSpPr>
-          <p:cNvPr id="10" name="Shape 8"/>
-          <p:cNvSpPr/>
-          <p:nvPr/>
-        </p:nvSpPr>
-        <p:spPr>
-          <a:xfrm>
-            <a:off x="548640" y="3886200"/>
-            <a:ext cx="11091672" cy="822960"/>
-          </a:xfrm>
-          <a:prstGeom prst="roundRect">
-            <a:avLst>
-              <a:gd name="adj" fmla="val 10000"/>
-            </a:avLst>
-          </a:prstGeom>
-          <a:solidFill>
-            <a:srgbClr val="E7F5F6"/>
-          </a:solidFill>
-          <a:ln/>
-          <a:effectLst>
-            <a:outerShdw sx="100000" sy="100000" kx="0" ky="0" algn="bl" rotWithShape="0" blurRad="76200" dist="25400" dir="5400000">
-              <a:srgbClr val="999999">
-                <a:alpha val="28000"/>
-              </a:srgbClr>
-            </a:outerShdw>
-          </a:effectLst>
-        </p:spPr>
-      </p:sp>
-      <p:sp>
-        <p:nvSpPr>
-          <p:cNvPr id="11" name="Text 9"/>
-          <p:cNvSpPr/>
-          <p:nvPr/>
-        </p:nvSpPr>
-        <p:spPr>
-          <a:xfrm>
-            <a:off x="10360152" y="3886200"/>
-            <a:ext cx="1097280" cy="822960"/>
+          <p:cNvPr id="17" name="Text 15"/>
+          <p:cNvSpPr/>
+          <p:nvPr/>
+        </p:nvSpPr>
+        <p:spPr>
+          <a:xfrm>
+            <a:off x="868680" y="4892040"/>
+            <a:ext cx="10451592" cy="594360"/>
           </a:xfrm>
           <a:prstGeom prst="rect">
             <a:avLst/>
@@ -14939,114 +15281,7 @@
               <a:buNone/>
             </a:pPr>
             <a:r>
-              <a:rPr lang="en-US" sz="1400" b="1" dirty="0">
-                <a:solidFill>
-                  <a:srgbClr val="0E9AA7"/>
-                </a:solidFill>
-                <a:latin typeface="Arial" pitchFamily="34" charset="0"/>
-                <a:ea typeface="Arial" pitchFamily="34" charset="-122"/>
-                <a:cs typeface="Arial" pitchFamily="34" charset="-120"/>
-              </a:rPr>
-              <a:t>בונוס:</a:t>
-            </a:r>
-            <a:endParaRPr lang="en-US" sz="1400" dirty="0"/>
-          </a:p>
-        </p:txBody>
-      </p:sp>
-      <p:sp>
-        <p:nvSpPr>
-          <p:cNvPr id="12" name="Text 10"/>
-          <p:cNvSpPr/>
-          <p:nvPr/>
-        </p:nvSpPr>
-        <p:spPr>
-          <a:xfrm>
-            <a:off x="822960" y="3886200"/>
-            <a:ext cx="9628632" cy="822960"/>
-          </a:xfrm>
-          <a:prstGeom prst="rect">
-            <a:avLst/>
-          </a:prstGeom>
-          <a:noFill/>
-          <a:ln/>
-        </p:spPr>
-        <p:txBody>
-          <a:bodyPr wrap="square" rtlCol="0" anchor="ctr"/>
-          <a:lstStyle/>
-          <a:p>
-            <a:pPr rtl="1" algn="r" indent="0" marL="0">
-              <a:buNone/>
-            </a:pPr>
-            <a:r>
-              <a:rPr lang="en-US" sz="1350" dirty="0">
-                <a:solidFill>
-                  <a:srgbClr val="222232"/>
-                </a:solidFill>
-                <a:latin typeface="Arial" pitchFamily="34" charset="0"/>
-                <a:ea typeface="Arial" pitchFamily="34" charset="-122"/>
-                <a:cs typeface="Arial" pitchFamily="34" charset="-120"/>
-              </a:rPr>
-              <a:t>בקשו מכל כלי לכתוב טסט אחד לפונקציה — האם הטסט תפס את מקרה הרשימה הריקה?</a:t>
-            </a:r>
-            <a:endParaRPr lang="en-US" sz="1350" dirty="0"/>
-          </a:p>
-        </p:txBody>
-      </p:sp>
-      <p:sp>
-        <p:nvSpPr>
-          <p:cNvPr id="13" name="Shape 11"/>
-          <p:cNvSpPr/>
-          <p:nvPr/>
-        </p:nvSpPr>
-        <p:spPr>
-          <a:xfrm>
-            <a:off x="548640" y="4892040"/>
-            <a:ext cx="11091672" cy="685800"/>
-          </a:xfrm>
-          <a:prstGeom prst="roundRect">
-            <a:avLst>
-              <a:gd name="adj" fmla="val 13333"/>
-            </a:avLst>
-          </a:prstGeom>
-          <a:solidFill>
-            <a:srgbClr val="9A6A00"/>
-          </a:solidFill>
-          <a:ln/>
-          <a:effectLst>
-            <a:outerShdw sx="100000" sy="100000" kx="0" ky="0" algn="bl" rotWithShape="0" blurRad="76200" dist="25400" dir="5400000">
-              <a:srgbClr val="999999">
-                <a:alpha val="28000"/>
-              </a:srgbClr>
-            </a:outerShdw>
-          </a:effectLst>
-        </p:spPr>
-      </p:sp>
-      <p:sp>
-        <p:nvSpPr>
-          <p:cNvPr id="14" name="Text 12"/>
-          <p:cNvSpPr/>
-          <p:nvPr/>
-        </p:nvSpPr>
-        <p:spPr>
-          <a:xfrm>
-            <a:off x="868680" y="5074920"/>
-            <a:ext cx="10451592" cy="320040"/>
-          </a:xfrm>
-          <a:prstGeom prst="rect">
-            <a:avLst/>
-          </a:prstGeom>
-          <a:noFill/>
-          <a:ln/>
-        </p:spPr>
-        <p:txBody>
-          <a:bodyPr wrap="square" rtlCol="0" anchor="ctr"/>
-          <a:lstStyle/>
-          <a:p>
-            <a:pPr rtl="1" algn="r" indent="0" marL="0">
-              <a:buNone/>
-            </a:pPr>
-            <a:r>
-              <a:rPr lang="en-US" sz="1600" b="1" dirty="0">
+              <a:rPr lang="en-US" sz="1550" b="1" dirty="0">
                 <a:solidFill>
                   <a:srgbClr val="FFFFFF"/>
                 </a:solidFill>
@@ -15054,15 +15289,15 @@
                 <a:ea typeface="Arial" pitchFamily="34" charset="-122"/>
                 <a:cs typeface="Arial" pitchFamily="34" charset="-120"/>
               </a:rPr>
-              <a:t>זכרו את כלל האצבע: אל תגישו קוד שלא הבנתם.</a:t>
-            </a:r>
-            <a:endParaRPr lang="en-US" sz="1600" dirty="0"/>
-          </a:p>
-        </p:txBody>
-      </p:sp>
-      <p:sp>
-        <p:nvSpPr>
-          <p:cNvPr id="15" name="Text 13"/>
+              <a:t>זהו “שלב 3” מהתהליך — הביקורת האנושית. קוד שלא טיפל ברשימה ריקה ייפול בחלוקה באפס. הבעיה מתגלה בהרצה, לא בקריאה.</a:t>
+            </a:r>
+            <a:endParaRPr lang="en-US" sz="1550" dirty="0"/>
+          </a:p>
+        </p:txBody>
+      </p:sp>
+      <p:sp>
+        <p:nvSpPr>
+          <p:cNvPr id="18" name="Text 16"/>
           <p:cNvSpPr/>
           <p:nvPr/>
         </p:nvSpPr>
@@ -15093,7 +15328,7 @@
                 <a:ea typeface="Arial" pitchFamily="34" charset="-122"/>
                 <a:cs typeface="Arial" pitchFamily="34" charset="-120"/>
               </a:rPr>
-              <a:t>25 / 26</a:t>
+              <a:t>25 / 27</a:t>
             </a:r>
             <a:endParaRPr lang="en-US" sz="950" dirty="0"/>
           </a:p>
@@ -15101,7 +15336,7 @@
       </p:sp>
       <p:sp>
         <p:nvSpPr>
-          <p:cNvPr id="16" name="Text 14"/>
+          <p:cNvPr id="19" name="Text 17"/>
           <p:cNvSpPr/>
           <p:nvPr/>
         </p:nvSpPr>
@@ -15149,6 +15384,689 @@
 <file path=ppt/slides/slide26.xml><?xml version="1.0" encoding="utf-8"?>
 <p:sld xmlns:a="http://schemas.openxmlformats.org/drawingml/2006/main" xmlns:r="http://schemas.openxmlformats.org/officeDocument/2006/relationships" xmlns:p="http://schemas.openxmlformats.org/presentationml/2006/main">
   <p:cSld name="Slide 26">
+    <p:bg>
+      <p:bgPr>
+        <a:solidFill>
+          <a:srgbClr val="FFFFFF"/>
+        </a:solidFill>
+      </p:bgPr>
+    </p:bg>
+    <p:spTree>
+      <p:nvGrpSpPr>
+        <p:cNvPr id="1" name=""/>
+        <p:cNvGrpSpPr/>
+        <p:nvPr/>
+      </p:nvGrpSpPr>
+      <p:grpSpPr>
+        <a:xfrm>
+          <a:off x="0" y="0"/>
+          <a:ext cx="0" cy="0"/>
+          <a:chOff x="0" y="0"/>
+          <a:chExt cx="0" cy="0"/>
+        </a:xfrm>
+      </p:grpSpPr>
+      <p:sp>
+        <p:nvSpPr>
+          <p:cNvPr id="2" name="Text 0"/>
+          <p:cNvSpPr/>
+          <p:nvPr/>
+        </p:nvSpPr>
+        <p:spPr>
+          <a:xfrm>
+            <a:off x="548640" y="384048"/>
+            <a:ext cx="11091672" cy="292608"/>
+          </a:xfrm>
+          <a:prstGeom prst="rect">
+            <a:avLst/>
+          </a:prstGeom>
+          <a:noFill/>
+          <a:ln/>
+        </p:spPr>
+        <p:txBody>
+          <a:bodyPr wrap="square" rtlCol="0" anchor="t"/>
+          <a:lstStyle/>
+          <a:p>
+            <a:pPr rtl="1" algn="r" indent="0" marL="0">
+              <a:buNone/>
+            </a:pPr>
+            <a:r>
+              <a:rPr lang="en-US" sz="1250" b="1" spc="100" kern="0" dirty="0">
+                <a:solidFill>
+                  <a:srgbClr val="0E9AA7"/>
+                </a:solidFill>
+                <a:latin typeface="Arial" pitchFamily="34" charset="0"/>
+                <a:ea typeface="Arial" pitchFamily="34" charset="-122"/>
+                <a:cs typeface="Arial" pitchFamily="34" charset="-120"/>
+              </a:rPr>
+              <a:t>הגשה</a:t>
+            </a:r>
+            <a:endParaRPr lang="en-US" sz="1250" dirty="0"/>
+          </a:p>
+        </p:txBody>
+      </p:sp>
+      <p:sp>
+        <p:nvSpPr>
+          <p:cNvPr id="3" name="Text 1"/>
+          <p:cNvSpPr/>
+          <p:nvPr/>
+        </p:nvSpPr>
+        <p:spPr>
+          <a:xfrm>
+            <a:off x="548640" y="676656"/>
+            <a:ext cx="11091672" cy="822960"/>
+          </a:xfrm>
+          <a:prstGeom prst="rect">
+            <a:avLst/>
+          </a:prstGeom>
+          <a:noFill/>
+          <a:ln/>
+        </p:spPr>
+        <p:txBody>
+          <a:bodyPr wrap="square" rtlCol="0" anchor="t"/>
+          <a:lstStyle/>
+          <a:p>
+            <a:pPr rtl="1" algn="r" indent="0" marL="0">
+              <a:buNone/>
+            </a:pPr>
+            <a:r>
+              <a:rPr lang="en-US" sz="3300" b="1" dirty="0">
+                <a:solidFill>
+                  <a:srgbClr val="1E2761"/>
+                </a:solidFill>
+                <a:latin typeface="Arial" pitchFamily="34" charset="0"/>
+                <a:ea typeface="Arial" pitchFamily="34" charset="-122"/>
+                <a:cs typeface="Arial" pitchFamily="34" charset="-120"/>
+              </a:rPr>
+              <a:t>קריטריוני הצלחה ותוצר</a:t>
+            </a:r>
+            <a:endParaRPr lang="en-US" sz="3300" dirty="0"/>
+          </a:p>
+        </p:txBody>
+      </p:sp>
+      <p:sp>
+        <p:nvSpPr>
+          <p:cNvPr id="4" name="Shape 2"/>
+          <p:cNvSpPr/>
+          <p:nvPr/>
+        </p:nvSpPr>
+        <p:spPr>
+          <a:xfrm>
+            <a:off x="6277356" y="1737360"/>
+            <a:ext cx="5362956" cy="1965960"/>
+          </a:xfrm>
+          <a:prstGeom prst="roundRect">
+            <a:avLst>
+              <a:gd name="adj" fmla="val 4186"/>
+            </a:avLst>
+          </a:prstGeom>
+          <a:solidFill>
+            <a:srgbClr val="EAF3EA"/>
+          </a:solidFill>
+          <a:ln/>
+          <a:effectLst>
+            <a:outerShdw sx="100000" sy="100000" kx="0" ky="0" algn="bl" rotWithShape="0" blurRad="76200" dist="25400" dir="5400000">
+              <a:srgbClr val="999999">
+                <a:alpha val="28000"/>
+              </a:srgbClr>
+            </a:outerShdw>
+          </a:effectLst>
+        </p:spPr>
+      </p:sp>
+      <p:sp>
+        <p:nvSpPr>
+          <p:cNvPr id="5" name="Text 3"/>
+          <p:cNvSpPr/>
+          <p:nvPr/>
+        </p:nvSpPr>
+        <p:spPr>
+          <a:xfrm>
+            <a:off x="6551676" y="1920240"/>
+            <a:ext cx="4814316" cy="365760"/>
+          </a:xfrm>
+          <a:prstGeom prst="rect">
+            <a:avLst/>
+          </a:prstGeom>
+          <a:noFill/>
+          <a:ln/>
+        </p:spPr>
+        <p:txBody>
+          <a:bodyPr wrap="square" rtlCol="0" anchor="t"/>
+          <a:lstStyle/>
+          <a:p>
+            <a:pPr rtl="1" algn="r" indent="0" marL="0">
+              <a:buNone/>
+            </a:pPr>
+            <a:r>
+              <a:rPr lang="en-US" sz="1500" b="1" dirty="0">
+                <a:solidFill>
+                  <a:srgbClr val="2E7D32"/>
+                </a:solidFill>
+                <a:latin typeface="Arial" pitchFamily="34" charset="0"/>
+                <a:ea typeface="Arial" pitchFamily="34" charset="-122"/>
+                <a:cs typeface="Arial" pitchFamily="34" charset="-120"/>
+              </a:rPr>
+              <a:t>הצלחתם אם...</a:t>
+            </a:r>
+            <a:endParaRPr lang="en-US" sz="1500" dirty="0"/>
+          </a:p>
+        </p:txBody>
+      </p:sp>
+      <p:sp>
+        <p:nvSpPr>
+          <p:cNvPr id="6" name="Text 4"/>
+          <p:cNvSpPr/>
+          <p:nvPr/>
+        </p:nvSpPr>
+        <p:spPr>
+          <a:xfrm>
+            <a:off x="6551676" y="2395728"/>
+            <a:ext cx="4814316" cy="1188720"/>
+          </a:xfrm>
+          <a:prstGeom prst="rect">
+            <a:avLst/>
+          </a:prstGeom>
+          <a:noFill/>
+          <a:ln/>
+        </p:spPr>
+        <p:txBody>
+          <a:bodyPr wrap="square" rtlCol="0" anchor="t"/>
+          <a:lstStyle/>
+          <a:p>
+            <a:pPr rtl="1" algn="r" indent="0" marL="0">
+              <a:lnSpc>
+                <a:spcPct val="135000"/>
+              </a:lnSpc>
+              <a:buNone/>
+            </a:pPr>
+            <a:r>
+              <a:rPr lang="en-US" sz="1450" dirty="0">
+                <a:solidFill>
+                  <a:srgbClr val="222232"/>
+                </a:solidFill>
+                <a:latin typeface="Arial" pitchFamily="34" charset="0"/>
+                <a:ea typeface="Arial" pitchFamily="34" charset="-122"/>
+                <a:cs typeface="Arial" pitchFamily="34" charset="-120"/>
+              </a:rPr>
+              <a:t>✓  הרצתם את הפרומפט ב-2 כלים</a:t>
+            </a:r>
+            <a:endParaRPr lang="en-US" sz="1450" dirty="0"/>
+          </a:p>
+          <a:p>
+            <a:pPr rtl="1" algn="r" indent="0" marL="0">
+              <a:lnSpc>
+                <a:spcPct val="135000"/>
+              </a:lnSpc>
+              <a:buNone/>
+            </a:pPr>
+            <a:r>
+              <a:rPr lang="en-US" sz="1450" dirty="0">
+                <a:solidFill>
+                  <a:srgbClr val="222232"/>
+                </a:solidFill>
+                <a:latin typeface="Arial" pitchFamily="34" charset="0"/>
+                <a:ea typeface="Arial" pitchFamily="34" charset="-122"/>
+                <a:cs typeface="Arial" pitchFamily="34" charset="-120"/>
+              </a:rPr>
+              <a:t>✓  השוויתם עברית מול אנגלית</a:t>
+            </a:r>
+            <a:endParaRPr lang="en-US" sz="1450" dirty="0"/>
+          </a:p>
+          <a:p>
+            <a:pPr rtl="1" algn="r" indent="0" marL="0">
+              <a:lnSpc>
+                <a:spcPct val="135000"/>
+              </a:lnSpc>
+              <a:buNone/>
+            </a:pPr>
+            <a:r>
+              <a:rPr lang="en-US" sz="1450" dirty="0">
+                <a:solidFill>
+                  <a:srgbClr val="222232"/>
+                </a:solidFill>
+                <a:latin typeface="Arial" pitchFamily="34" charset="0"/>
+                <a:ea typeface="Arial" pitchFamily="34" charset="-122"/>
+                <a:cs typeface="Arial" pitchFamily="34" charset="-120"/>
+              </a:rPr>
+              <a:t>✓  הרצתם בפועל — כולל רשימה ריקה</a:t>
+            </a:r>
+            <a:endParaRPr lang="en-US" sz="1450" dirty="0"/>
+          </a:p>
+        </p:txBody>
+      </p:sp>
+      <p:sp>
+        <p:nvSpPr>
+          <p:cNvPr id="7" name="Shape 5"/>
+          <p:cNvSpPr/>
+          <p:nvPr/>
+        </p:nvSpPr>
+        <p:spPr>
+          <a:xfrm>
+            <a:off x="548640" y="1737360"/>
+            <a:ext cx="5362956" cy="1965960"/>
+          </a:xfrm>
+          <a:prstGeom prst="roundRect">
+            <a:avLst>
+              <a:gd name="adj" fmla="val 4186"/>
+            </a:avLst>
+          </a:prstGeom>
+          <a:solidFill>
+            <a:srgbClr val="F2F3FA"/>
+          </a:solidFill>
+          <a:ln/>
+          <a:effectLst>
+            <a:outerShdw sx="100000" sy="100000" kx="0" ky="0" algn="bl" rotWithShape="0" blurRad="76200" dist="25400" dir="5400000">
+              <a:srgbClr val="999999">
+                <a:alpha val="28000"/>
+              </a:srgbClr>
+            </a:outerShdw>
+          </a:effectLst>
+        </p:spPr>
+      </p:sp>
+      <p:sp>
+        <p:nvSpPr>
+          <p:cNvPr id="8" name="Text 6"/>
+          <p:cNvSpPr/>
+          <p:nvPr/>
+        </p:nvSpPr>
+        <p:spPr>
+          <a:xfrm>
+            <a:off x="822960" y="1920240"/>
+            <a:ext cx="4814316" cy="365760"/>
+          </a:xfrm>
+          <a:prstGeom prst="rect">
+            <a:avLst/>
+          </a:prstGeom>
+          <a:noFill/>
+          <a:ln/>
+        </p:spPr>
+        <p:txBody>
+          <a:bodyPr wrap="square" rtlCol="0" anchor="t"/>
+          <a:lstStyle/>
+          <a:p>
+            <a:pPr rtl="1" algn="r" indent="0" marL="0">
+              <a:buNone/>
+            </a:pPr>
+            <a:r>
+              <a:rPr lang="en-US" sz="1500" b="1" dirty="0">
+                <a:solidFill>
+                  <a:srgbClr val="1E2761"/>
+                </a:solidFill>
+                <a:latin typeface="Arial" pitchFamily="34" charset="0"/>
+                <a:ea typeface="Arial" pitchFamily="34" charset="-122"/>
+                <a:cs typeface="Arial" pitchFamily="34" charset="-120"/>
+              </a:rPr>
+              <a:t>תוצר להגשה (חצי עמוד)</a:t>
+            </a:r>
+            <a:endParaRPr lang="en-US" sz="1500" dirty="0"/>
+          </a:p>
+        </p:txBody>
+      </p:sp>
+      <p:sp>
+        <p:nvSpPr>
+          <p:cNvPr id="9" name="Text 7"/>
+          <p:cNvSpPr/>
+          <p:nvPr/>
+        </p:nvSpPr>
+        <p:spPr>
+          <a:xfrm>
+            <a:off x="822960" y="2359152"/>
+            <a:ext cx="4814316" cy="1280160"/>
+          </a:xfrm>
+          <a:prstGeom prst="rect">
+            <a:avLst/>
+          </a:prstGeom>
+          <a:noFill/>
+          <a:ln/>
+        </p:spPr>
+        <p:txBody>
+          <a:bodyPr wrap="square" rtlCol="0" anchor="t"/>
+          <a:lstStyle/>
+          <a:p>
+            <a:pPr rtl="1" algn="r" indent="0" marL="0">
+              <a:lnSpc>
+                <a:spcPct val="128000"/>
+              </a:lnSpc>
+              <a:buNone/>
+            </a:pPr>
+            <a:r>
+              <a:rPr lang="en-US" sz="1350" dirty="0">
+                <a:solidFill>
+                  <a:srgbClr val="222232"/>
+                </a:solidFill>
+                <a:latin typeface="Arial" pitchFamily="34" charset="0"/>
+                <a:ea typeface="Arial" pitchFamily="34" charset="-122"/>
+                <a:cs typeface="Arial" pitchFamily="34" charset="-120"/>
+              </a:rPr>
+              <a:t>•  הכלים שבהם השתמשתם</a:t>
+            </a:r>
+            <a:endParaRPr lang="en-US" sz="1350" dirty="0"/>
+          </a:p>
+          <a:p>
+            <a:pPr rtl="1" algn="r" indent="0" marL="0">
+              <a:lnSpc>
+                <a:spcPct val="128000"/>
+              </a:lnSpc>
+              <a:buNone/>
+            </a:pPr>
+            <a:r>
+              <a:rPr lang="en-US" sz="1350" dirty="0">
+                <a:solidFill>
+                  <a:srgbClr val="222232"/>
+                </a:solidFill>
+                <a:latin typeface="Arial" pitchFamily="34" charset="0"/>
+                <a:ea typeface="Arial" pitchFamily="34" charset="-122"/>
+                <a:cs typeface="Arial" pitchFamily="34" charset="-120"/>
+              </a:rPr>
+              <a:t>•  ההבדלים בין הכלים</a:t>
+            </a:r>
+            <a:endParaRPr lang="en-US" sz="1350" dirty="0"/>
+          </a:p>
+          <a:p>
+            <a:pPr rtl="1" algn="r" indent="0" marL="0">
+              <a:lnSpc>
+                <a:spcPct val="128000"/>
+              </a:lnSpc>
+              <a:buNone/>
+            </a:pPr>
+            <a:r>
+              <a:rPr lang="en-US" sz="1350" dirty="0">
+                <a:solidFill>
+                  <a:srgbClr val="222232"/>
+                </a:solidFill>
+                <a:latin typeface="Arial" pitchFamily="34" charset="0"/>
+                <a:ea typeface="Arial" pitchFamily="34" charset="-122"/>
+                <a:cs typeface="Arial" pitchFamily="34" charset="-120"/>
+              </a:rPr>
+              <a:t>•  ההבדל בין עברית לאנגלית (אם היה)</a:t>
+            </a:r>
+            <a:endParaRPr lang="en-US" sz="1350" dirty="0"/>
+          </a:p>
+          <a:p>
+            <a:pPr rtl="1" algn="r" indent="0" marL="0">
+              <a:lnSpc>
+                <a:spcPct val="128000"/>
+              </a:lnSpc>
+              <a:buNone/>
+            </a:pPr>
+            <a:r>
+              <a:rPr lang="en-US" sz="1350" dirty="0">
+                <a:solidFill>
+                  <a:srgbClr val="222232"/>
+                </a:solidFill>
+                <a:latin typeface="Arial" pitchFamily="34" charset="0"/>
+                <a:ea typeface="Arial" pitchFamily="34" charset="-122"/>
+                <a:cs typeface="Arial" pitchFamily="34" charset="-120"/>
+              </a:rPr>
+              <a:t>•  מי טיפל נכון במקרה הקצה</a:t>
+            </a:r>
+            <a:endParaRPr lang="en-US" sz="1350" dirty="0"/>
+          </a:p>
+        </p:txBody>
+      </p:sp>
+      <p:sp>
+        <p:nvSpPr>
+          <p:cNvPr id="10" name="Shape 8"/>
+          <p:cNvSpPr/>
+          <p:nvPr/>
+        </p:nvSpPr>
+        <p:spPr>
+          <a:xfrm>
+            <a:off x="548640" y="3886200"/>
+            <a:ext cx="11091672" cy="822960"/>
+          </a:xfrm>
+          <a:prstGeom prst="roundRect">
+            <a:avLst>
+              <a:gd name="adj" fmla="val 10000"/>
+            </a:avLst>
+          </a:prstGeom>
+          <a:solidFill>
+            <a:srgbClr val="E7F5F6"/>
+          </a:solidFill>
+          <a:ln/>
+          <a:effectLst>
+            <a:outerShdw sx="100000" sy="100000" kx="0" ky="0" algn="bl" rotWithShape="0" blurRad="76200" dist="25400" dir="5400000">
+              <a:srgbClr val="999999">
+                <a:alpha val="28000"/>
+              </a:srgbClr>
+            </a:outerShdw>
+          </a:effectLst>
+        </p:spPr>
+      </p:sp>
+      <p:sp>
+        <p:nvSpPr>
+          <p:cNvPr id="11" name="Text 9"/>
+          <p:cNvSpPr/>
+          <p:nvPr/>
+        </p:nvSpPr>
+        <p:spPr>
+          <a:xfrm>
+            <a:off x="10360152" y="3886200"/>
+            <a:ext cx="1097280" cy="822960"/>
+          </a:xfrm>
+          <a:prstGeom prst="rect">
+            <a:avLst/>
+          </a:prstGeom>
+          <a:noFill/>
+          <a:ln/>
+        </p:spPr>
+        <p:txBody>
+          <a:bodyPr wrap="square" rtlCol="0" anchor="ctr"/>
+          <a:lstStyle/>
+          <a:p>
+            <a:pPr rtl="1" algn="r" indent="0" marL="0">
+              <a:buNone/>
+            </a:pPr>
+            <a:r>
+              <a:rPr lang="en-US" sz="1400" b="1" dirty="0">
+                <a:solidFill>
+                  <a:srgbClr val="0E9AA7"/>
+                </a:solidFill>
+                <a:latin typeface="Arial" pitchFamily="34" charset="0"/>
+                <a:ea typeface="Arial" pitchFamily="34" charset="-122"/>
+                <a:cs typeface="Arial" pitchFamily="34" charset="-120"/>
+              </a:rPr>
+              <a:t>בונוס:</a:t>
+            </a:r>
+            <a:endParaRPr lang="en-US" sz="1400" dirty="0"/>
+          </a:p>
+        </p:txBody>
+      </p:sp>
+      <p:sp>
+        <p:nvSpPr>
+          <p:cNvPr id="12" name="Text 10"/>
+          <p:cNvSpPr/>
+          <p:nvPr/>
+        </p:nvSpPr>
+        <p:spPr>
+          <a:xfrm>
+            <a:off x="822960" y="3886200"/>
+            <a:ext cx="9628632" cy="822960"/>
+          </a:xfrm>
+          <a:prstGeom prst="rect">
+            <a:avLst/>
+          </a:prstGeom>
+          <a:noFill/>
+          <a:ln/>
+        </p:spPr>
+        <p:txBody>
+          <a:bodyPr wrap="square" rtlCol="0" anchor="ctr"/>
+          <a:lstStyle/>
+          <a:p>
+            <a:pPr rtl="1" algn="r" indent="0" marL="0">
+              <a:buNone/>
+            </a:pPr>
+            <a:r>
+              <a:rPr lang="en-US" sz="1350" dirty="0">
+                <a:solidFill>
+                  <a:srgbClr val="222232"/>
+                </a:solidFill>
+                <a:latin typeface="Arial" pitchFamily="34" charset="0"/>
+                <a:ea typeface="Arial" pitchFamily="34" charset="-122"/>
+                <a:cs typeface="Arial" pitchFamily="34" charset="-120"/>
+              </a:rPr>
+              <a:t>בקשו מכל כלי לכתוב טסט אחד לפונקציה — האם הטסט תפס את מקרה הרשימה הריקה?</a:t>
+            </a:r>
+            <a:endParaRPr lang="en-US" sz="1350" dirty="0"/>
+          </a:p>
+        </p:txBody>
+      </p:sp>
+      <p:sp>
+        <p:nvSpPr>
+          <p:cNvPr id="13" name="Shape 11"/>
+          <p:cNvSpPr/>
+          <p:nvPr/>
+        </p:nvSpPr>
+        <p:spPr>
+          <a:xfrm>
+            <a:off x="548640" y="4892040"/>
+            <a:ext cx="11091672" cy="685800"/>
+          </a:xfrm>
+          <a:prstGeom prst="roundRect">
+            <a:avLst>
+              <a:gd name="adj" fmla="val 13333"/>
+            </a:avLst>
+          </a:prstGeom>
+          <a:solidFill>
+            <a:srgbClr val="9A6A00"/>
+          </a:solidFill>
+          <a:ln/>
+          <a:effectLst>
+            <a:outerShdw sx="100000" sy="100000" kx="0" ky="0" algn="bl" rotWithShape="0" blurRad="76200" dist="25400" dir="5400000">
+              <a:srgbClr val="999999">
+                <a:alpha val="28000"/>
+              </a:srgbClr>
+            </a:outerShdw>
+          </a:effectLst>
+        </p:spPr>
+      </p:sp>
+      <p:sp>
+        <p:nvSpPr>
+          <p:cNvPr id="14" name="Text 12"/>
+          <p:cNvSpPr/>
+          <p:nvPr/>
+        </p:nvSpPr>
+        <p:spPr>
+          <a:xfrm>
+            <a:off x="868680" y="5074920"/>
+            <a:ext cx="10451592" cy="320040"/>
+          </a:xfrm>
+          <a:prstGeom prst="rect">
+            <a:avLst/>
+          </a:prstGeom>
+          <a:noFill/>
+          <a:ln/>
+        </p:spPr>
+        <p:txBody>
+          <a:bodyPr wrap="square" rtlCol="0" anchor="ctr"/>
+          <a:lstStyle/>
+          <a:p>
+            <a:pPr rtl="1" algn="r" indent="0" marL="0">
+              <a:buNone/>
+            </a:pPr>
+            <a:r>
+              <a:rPr lang="en-US" sz="1600" b="1" dirty="0">
+                <a:solidFill>
+                  <a:srgbClr val="FFFFFF"/>
+                </a:solidFill>
+                <a:latin typeface="Arial" pitchFamily="34" charset="0"/>
+                <a:ea typeface="Arial" pitchFamily="34" charset="-122"/>
+                <a:cs typeface="Arial" pitchFamily="34" charset="-120"/>
+              </a:rPr>
+              <a:t>זכרו את כלל האצבע: אל תגישו קוד שלא הבנתם.</a:t>
+            </a:r>
+            <a:endParaRPr lang="en-US" sz="1600" dirty="0"/>
+          </a:p>
+        </p:txBody>
+      </p:sp>
+      <p:sp>
+        <p:nvSpPr>
+          <p:cNvPr id="15" name="Text 13"/>
+          <p:cNvSpPr/>
+          <p:nvPr/>
+        </p:nvSpPr>
+        <p:spPr>
+          <a:xfrm>
+            <a:off x="548640" y="6419088"/>
+            <a:ext cx="1828800" cy="274320"/>
+          </a:xfrm>
+          <a:prstGeom prst="rect">
+            <a:avLst/>
+          </a:prstGeom>
+          <a:noFill/>
+          <a:ln/>
+        </p:spPr>
+        <p:txBody>
+          <a:bodyPr wrap="square" rtlCol="0" anchor="ctr"/>
+          <a:lstStyle/>
+          <a:p>
+            <a:pPr algn="l" indent="0" marL="0">
+              <a:buNone/>
+            </a:pPr>
+            <a:r>
+              <a:rPr lang="en-US" sz="950" dirty="0">
+                <a:solidFill>
+                  <a:srgbClr val="6B6B80"/>
+                </a:solidFill>
+                <a:latin typeface="Arial" pitchFamily="34" charset="0"/>
+                <a:ea typeface="Arial" pitchFamily="34" charset="-122"/>
+                <a:cs typeface="Arial" pitchFamily="34" charset="-120"/>
+              </a:rPr>
+              <a:t>26 / 27</a:t>
+            </a:r>
+            <a:endParaRPr lang="en-US" sz="950" dirty="0"/>
+          </a:p>
+        </p:txBody>
+      </p:sp>
+      <p:sp>
+        <p:nvSpPr>
+          <p:cNvPr id="16" name="Text 14"/>
+          <p:cNvSpPr/>
+          <p:nvPr/>
+        </p:nvSpPr>
+        <p:spPr>
+          <a:xfrm>
+            <a:off x="7982712" y="6419088"/>
+            <a:ext cx="3657600" cy="274320"/>
+          </a:xfrm>
+          <a:prstGeom prst="rect">
+            <a:avLst/>
+          </a:prstGeom>
+          <a:noFill/>
+          <a:ln/>
+        </p:spPr>
+        <p:txBody>
+          <a:bodyPr wrap="square" rtlCol="0" anchor="t"/>
+          <a:lstStyle/>
+          <a:p>
+            <a:pPr rtl="1" algn="r" indent="0" marL="0">
+              <a:buNone/>
+            </a:pPr>
+            <a:r>
+              <a:rPr lang="en-US" sz="950" dirty="0">
+                <a:solidFill>
+                  <a:srgbClr val="6B6B80"/>
+                </a:solidFill>
+                <a:latin typeface="Arial" pitchFamily="34" charset="0"/>
+                <a:ea typeface="Arial" pitchFamily="34" charset="-122"/>
+                <a:cs typeface="Arial" pitchFamily="34" charset="-120"/>
+              </a:rPr>
+              <a:t>Vibe Coding · מפגש 1</a:t>
+            </a:r>
+            <a:endParaRPr lang="en-US" sz="950" dirty="0"/>
+          </a:p>
+        </p:txBody>
+      </p:sp>
+    </p:spTree>
+  </p:cSld>
+  <p:clrMapOvr>
+    <a:masterClrMapping/>
+  </p:clrMapOvr>
+</p:sld>
+</file>
+
+<file path=ppt/slides/slide27.xml><?xml version="1.0" encoding="utf-8"?>
+<p:sld xmlns:a="http://schemas.openxmlformats.org/drawingml/2006/main" xmlns:r="http://schemas.openxmlformats.org/officeDocument/2006/relationships" xmlns:p="http://schemas.openxmlformats.org/presentationml/2006/main">
+  <p:cSld name="Slide 27">
     <p:bg>
       <p:bgPr>
         <a:solidFill>
@@ -15320,7 +16238,7 @@
                 <a:ea typeface="Arial" pitchFamily="34" charset="-122"/>
                 <a:cs typeface="Arial" pitchFamily="34" charset="-120"/>
               </a:rPr>
-              <a:t>26 / 26</a:t>
+              <a:t>27 / 27</a:t>
             </a:r>
             <a:endParaRPr lang="en-US" sz="950" dirty="0"/>
           </a:p>
@@ -15785,7 +16703,7 @@
                 <a:ea typeface="Arial" pitchFamily="34" charset="-122"/>
                 <a:cs typeface="Arial" pitchFamily="34" charset="-120"/>
               </a:rPr>
-              <a:t>03 / 26</a:t>
+              <a:t>03 / 27</a:t>
             </a:r>
             <a:endParaRPr lang="en-US" sz="950" dirty="0"/>
           </a:p>
@@ -16187,7 +17105,7 @@
                 <a:ea typeface="Arial" pitchFamily="34" charset="-122"/>
                 <a:cs typeface="Arial" pitchFamily="34" charset="-120"/>
               </a:rPr>
-              <a:t>04 / 26</a:t>
+              <a:t>04 / 27</a:t>
             </a:r>
             <a:endParaRPr lang="en-US" sz="950" dirty="0"/>
           </a:p>
@@ -16732,7 +17650,7 @@
                 <a:ea typeface="Arial" pitchFamily="34" charset="-122"/>
                 <a:cs typeface="Arial" pitchFamily="34" charset="-120"/>
               </a:rPr>
-              <a:t>05 / 26</a:t>
+              <a:t>05 / 27</a:t>
             </a:r>
             <a:endParaRPr lang="en-US" sz="950" dirty="0"/>
           </a:p>
@@ -17501,7 +18419,7 @@
                 <a:ea typeface="Arial" pitchFamily="34" charset="-122"/>
                 <a:cs typeface="Arial" pitchFamily="34" charset="-120"/>
               </a:rPr>
-              <a:t>06 / 26</a:t>
+              <a:t>06 / 27</a:t>
             </a:r>
             <a:endParaRPr lang="en-US" sz="950" dirty="0"/>
           </a:p>
@@ -17988,7 +18906,7 @@
                 <a:ea typeface="Arial" pitchFamily="34" charset="-122"/>
                 <a:cs typeface="Arial" pitchFamily="34" charset="-120"/>
               </a:rPr>
-              <a:t>07 / 26</a:t>
+              <a:t>07 / 27</a:t>
             </a:r>
             <a:endParaRPr lang="en-US" sz="950" dirty="0"/>
           </a:p>
@@ -18549,7 +19467,7 @@
                 <a:ea typeface="Arial" pitchFamily="34" charset="-122"/>
                 <a:cs typeface="Arial" pitchFamily="34" charset="-120"/>
               </a:rPr>
-              <a:t>08 / 26</a:t>
+              <a:t>08 / 27</a:t>
             </a:r>
             <a:endParaRPr lang="en-US" sz="950" dirty="0"/>
           </a:p>
@@ -19165,7 +20083,7 @@
                 <a:ea typeface="Arial" pitchFamily="34" charset="-122"/>
                 <a:cs typeface="Arial" pitchFamily="34" charset="-120"/>
               </a:rPr>
-              <a:t>09 / 26</a:t>
+              <a:t>09 / 27</a:t>
             </a:r>
             <a:endParaRPr lang="en-US" sz="950" dirty="0"/>
           </a:p>

</xml_diff>